<commit_message>
feat: Expand vector store with WITSML data to 36,709 documents, add 4 new agent tools, update presentation metrics, and increase test coverage to 95.
</commit_message>
<xml_diff>
--- a/presentation/slides.pptx
+++ b/presentation/slides.pptx
@@ -3624,7 +3624,7 @@
               </a:defRPr>
             </a:pPr>
             <a:r>
-              <a:t>Robust: 95 tests, 130 stress questions, data quality filtering, API retry logic</a:t>
+              <a:t>Robust: 95 tests, 50-question stress test, +0.43 after targeted fixes</a:t>
             </a:r>
           </a:p>
           <a:p>
@@ -8733,7 +8733,7 @@
               </a:defRPr>
             </a:pPr>
             <a:r>
-              <a:t>GPT-5.4 mini with reasoning_effort=high</a:t>
+              <a:t>GPT-5.4 mini configured for reasoning_effort=high</a:t>
             </a:r>
           </a:p>
           <a:p>
@@ -8765,7 +8765,7 @@
               </a:defRPr>
             </a:pPr>
             <a:r>
-              <a:t>Graceful fallback for older models</a:t>
+              <a:t>Graceful runtime fallback when unsupported</a:t>
             </a:r>
           </a:p>
         </p:txBody>
@@ -8942,7 +8942,23 @@
               </a:defRPr>
             </a:pPr>
             <a:r>
-              <a:t>95 automated tests, 130 stress-test questions</a:t>
+              <a:t>95 automated tests, 50-question primary stress test</a:t>
+            </a:r>
+          </a:p>
+          <a:p>
+            <a:pPr lvl="1">
+              <a:spcAft>
+                <a:spcPts val="400"/>
+              </a:spcAft>
+              <a:defRPr sz="1300">
+                <a:solidFill>
+                  <a:srgbClr val="666666"/>
+                </a:solidFill>
+                <a:latin typeface="Calibri"/>
+              </a:defRPr>
+            </a:pPr>
+            <a:r>
+              <a:t>Baseline avg 7.59/10 -&gt; 8.02/10 after fixes</a:t>
             </a:r>
           </a:p>
           <a:p>

</xml_diff>

<commit_message>
feat: Update documentation and presentation to reflect the 130-question stress test suite.
</commit_message>
<xml_diff>
--- a/presentation/slides.pptx
+++ b/presentation/slides.pptx
@@ -3624,7 +3624,7 @@
               </a:defRPr>
             </a:pPr>
             <a:r>
-              <a:t>Robust: 95 tests, 50-question stress test, +0.43 after targeted fixes</a:t>
+              <a:t>Robust: 95 tests, 130-question stress test, +0.43 after targeted fixes</a:t>
             </a:r>
           </a:p>
           <a:p>
@@ -8942,7 +8942,7 @@
               </a:defRPr>
             </a:pPr>
             <a:r>
-              <a:t>95 automated tests, 50-question primary stress test</a:t>
+              <a:t>95 automated tests, 130-question primary stress test</a:t>
             </a:r>
           </a:p>
           <a:p>

</xml_diff>

<commit_message>
docs: Remove self-promotional language from slides, add How to Run
- Replace "Why This Solution Wins" -> "Summary & How to Run" with
  quick-start commands judges can copy-paste
- Replace "Key Differentiators" -> "How Evidence is Gathered" (factual)
- Remove "No LangChain, no framework bloat" (defensive)
- Remove "Turns the black box into a glass box" (marketing)
- Remove internal stress test score delta (7.59->8.02)
- Remove judge quote attribution
- All language now descriptive and factual, not promotional

Co-Authored-By: Claude Opus 4.6 (1M context) <noreply@anthropic.com>
</commit_message>
<xml_diff>
--- a/presentation/slides.pptx
+++ b/presentation/slides.pptx
@@ -3368,7 +3368,7 @@
         </p:nvSpPr>
         <p:spPr>
           <a:xfrm>
-            <a:off x="0" y="2743200"/>
+            <a:off x="0" y="3108960"/>
             <a:ext cx="12191695" cy="36576"/>
           </a:xfrm>
           <a:prstGeom prst="rect">
@@ -3411,7 +3411,7 @@
         </p:nvSpPr>
         <p:spPr>
           <a:xfrm>
-            <a:off x="1097280" y="548640"/>
+            <a:off x="1097280" y="457200"/>
             <a:ext cx="10058400" cy="731520"/>
           </a:xfrm>
           <a:prstGeom prst="rect">
@@ -3434,7 +3434,7 @@
               </a:defRPr>
             </a:pPr>
             <a:r>
-              <a:t>Why This Solution Wins</a:t>
+              <a:t>Summary &amp; How to Run</a:t>
             </a:r>
           </a:p>
         </p:txBody>
@@ -3447,8 +3447,8 @@
         </p:nvSpPr>
         <p:spPr>
           <a:xfrm>
-            <a:off x="1371600" y="1463040"/>
-            <a:ext cx="9418320" cy="1097280"/>
+            <a:off x="1371600" y="1280160"/>
+            <a:ext cx="4572000" cy="1645920"/>
           </a:xfrm>
           <a:prstGeom prst="rect">
             <a:avLst/>
@@ -3465,7 +3465,7 @@
               <a:spcAft>
                 <a:spcPts val="400"/>
               </a:spcAft>
-              <a:defRPr sz="1600">
+              <a:defRPr sz="1500">
                 <a:solidFill>
                   <a:srgbClr val="CCDDEE"/>
                 </a:solidFill>
@@ -3473,39 +3473,71 @@
               </a:defRPr>
             </a:pPr>
             <a:r>
-              <a:t>12 DuckDB tables from 4 data sources (DDR + WITSML + production + geology)</a:t>
-            </a:r>
-          </a:p>
-          <a:p>
-            <a:pPr>
-              <a:spcAft>
-                <a:spcPts val="400"/>
-              </a:spcAft>
-              <a:defRPr sz="1600">
-                <a:solidFill>
-                  <a:srgbClr val="CCDDEE"/>
-                </a:solidFill>
-                <a:latin typeface="Calibri"/>
-              </a:defRPr>
-            </a:pPr>
-            <a:r>
-              <a:t>12 purpose-built agent tools covering all 6 question categories + cross-well benchmarks</a:t>
-            </a:r>
-          </a:p>
-          <a:p>
-            <a:pPr>
-              <a:spcAft>
-                <a:spcPts val="400"/>
-              </a:spcAft>
-              <a:defRPr sz="1600">
-                <a:solidFill>
-                  <a:srgbClr val="CCDDEE"/>
-                </a:solidFill>
-                <a:latin typeface="Calibri"/>
-              </a:defRPr>
-            </a:pPr>
-            <a:r>
-              <a:t>~38,000 searchable documents in ChromaDB vector store (DDR text + WITSML messages)</a:t>
+              <a:t>System at a Glance</a:t>
+            </a:r>
+          </a:p>
+          <a:p>
+            <a:pPr lvl="1">
+              <a:spcAft>
+                <a:spcPts val="400"/>
+              </a:spcAft>
+              <a:defRPr sz="1300">
+                <a:solidFill>
+                  <a:srgbClr val="99BBDD"/>
+                </a:solidFill>
+                <a:latin typeface="Calibri"/>
+              </a:defRPr>
+            </a:pPr>
+            <a:r>
+              <a:t>12 DuckDB tables from 4 data sources</a:t>
+            </a:r>
+          </a:p>
+          <a:p>
+            <a:pPr lvl="1">
+              <a:spcAft>
+                <a:spcPts val="400"/>
+              </a:spcAft>
+              <a:defRPr sz="1300">
+                <a:solidFill>
+                  <a:srgbClr val="99BBDD"/>
+                </a:solidFill>
+                <a:latin typeface="Calibri"/>
+              </a:defRPr>
+            </a:pPr>
+            <a:r>
+              <a:t>12 agent tools covering all 6 question categories</a:t>
+            </a:r>
+          </a:p>
+          <a:p>
+            <a:pPr lvl="1">
+              <a:spcAft>
+                <a:spcPts val="400"/>
+              </a:spcAft>
+              <a:defRPr sz="1300">
+                <a:solidFill>
+                  <a:srgbClr val="99BBDD"/>
+                </a:solidFill>
+                <a:latin typeface="Calibri"/>
+              </a:defRPr>
+            </a:pPr>
+            <a:r>
+              <a:t>36,709 searchable documents in ChromaDB</a:t>
+            </a:r>
+          </a:p>
+          <a:p>
+            <a:pPr lvl="1">
+              <a:spcAft>
+                <a:spcPts val="400"/>
+              </a:spcAft>
+              <a:defRPr sz="1300">
+                <a:solidFill>
+                  <a:srgbClr val="99BBDD"/>
+                </a:solidFill>
+                <a:latin typeface="Calibri"/>
+              </a:defRPr>
+            </a:pPr>
+            <a:r>
+              <a:t>95 unit tests + 130-question stress test</a:t>
             </a:r>
           </a:p>
         </p:txBody>
@@ -3518,8 +3550,8 @@
         </p:nvSpPr>
         <p:spPr>
           <a:xfrm>
-            <a:off x="1371600" y="3017520"/>
-            <a:ext cx="9418320" cy="3200400"/>
+            <a:off x="6400800" y="1280160"/>
+            <a:ext cx="5029200" cy="1645920"/>
           </a:xfrm>
           <a:prstGeom prst="rect">
             <a:avLst/>
@@ -3538,109 +3570,77 @@
               </a:spcAft>
               <a:defRPr sz="1500">
                 <a:solidFill>
-                  <a:srgbClr val="FFFFFF"/>
-                </a:solidFill>
-                <a:latin typeface="Calibri"/>
-              </a:defRPr>
-            </a:pPr>
-            <a:r>
-              <a:t>Evidence-first: every answer cites BOTH data AND daily report quotes</a:t>
-            </a:r>
-          </a:p>
-          <a:p>
-            <a:pPr>
-              <a:spcAft>
-                <a:spcPts val="400"/>
-              </a:spcAft>
-              <a:defRPr sz="1500">
-                <a:solidFill>
-                  <a:srgbClr val="FFFFFF"/>
-                </a:solidFill>
-                <a:latin typeface="Calibri"/>
-              </a:defRPr>
-            </a:pPr>
-            <a:r>
-              <a:t>Transparent: --trace shows complete reasoning chain for every answer</a:t>
-            </a:r>
-          </a:p>
-          <a:p>
-            <a:pPr>
-              <a:spcAft>
-                <a:spcPts val="400"/>
-              </a:spcAft>
-              <a:defRPr sz="1500">
-                <a:solidFill>
-                  <a:srgbClr val="FFFFFF"/>
-                </a:solidFill>
-                <a:latin typeface="Calibri"/>
-              </a:defRPr>
-            </a:pPr>
-            <a:r>
-              <a:t>Domain-appropriate: hole-size phase detection, NPT sub-classification, mud correlation</a:t>
-            </a:r>
-          </a:p>
-          <a:p>
-            <a:pPr>
-              <a:spcAft>
-                <a:spcPts val="400"/>
-              </a:spcAft>
-              <a:defRPr sz="1500">
-                <a:solidFill>
-                  <a:srgbClr val="FFFFFF"/>
-                </a:solidFill>
-                <a:latin typeface="Calibri"/>
-              </a:defRPr>
-            </a:pPr>
-            <a:r>
-              <a:t>Deep data integration: actual measured ROP/WOB/RPM from WITSML mudlog</a:t>
-            </a:r>
-          </a:p>
-          <a:p>
-            <a:pPr>
-              <a:spcAft>
-                <a:spcPts val="400"/>
-              </a:spcAft>
-              <a:defRPr sz="1500">
-                <a:solidFill>
-                  <a:srgbClr val="FFFFFF"/>
-                </a:solidFill>
-                <a:latin typeface="Calibri"/>
-              </a:defRPr>
-            </a:pPr>
-            <a:r>
-              <a:t>Cross-well analysis: field-wide benchmarks, difficulty indices, gas response ranking</a:t>
-            </a:r>
-          </a:p>
-          <a:p>
-            <a:pPr>
-              <a:spcAft>
-                <a:spcPts val="400"/>
-              </a:spcAft>
-              <a:defRPr sz="1500">
-                <a:solidFill>
-                  <a:srgbClr val="FFFFFF"/>
-                </a:solidFill>
-                <a:latin typeface="Calibri"/>
-              </a:defRPr>
-            </a:pPr>
-            <a:r>
-              <a:t>Robust: 95 tests, 130-question stress test, +0.43 after targeted fixes</a:t>
-            </a:r>
-          </a:p>
-          <a:p>
-            <a:pPr>
-              <a:spcAft>
-                <a:spcPts val="400"/>
-              </a:spcAft>
-              <a:defRPr sz="1500">
-                <a:solidFill>
-                  <a:srgbClr val="FFFFFF"/>
-                </a:solidFill>
-                <a:latin typeface="Calibri"/>
-              </a:defRPr>
-            </a:pPr>
-            <a:r>
-              <a:t>Reproducible: pip install, set API key, ingest (~3 min), ask questions</a:t>
+                  <a:srgbClr val="CCDDEE"/>
+                </a:solidFill>
+                <a:latin typeface="Calibri"/>
+              </a:defRPr>
+            </a:pPr>
+            <a:r>
+              <a:t>Answer Format (every response)</a:t>
+            </a:r>
+          </a:p>
+          <a:p>
+            <a:pPr lvl="1">
+              <a:spcAft>
+                <a:spcPts val="400"/>
+              </a:spcAft>
+              <a:defRPr sz="1300">
+                <a:solidFill>
+                  <a:srgbClr val="99BBDD"/>
+                </a:solidFill>
+                <a:latin typeface="Calibri"/>
+              </a:defRPr>
+            </a:pPr>
+            <a:r>
+              <a:t>Structured data evidence with measurements</a:t>
+            </a:r>
+          </a:p>
+          <a:p>
+            <a:pPr lvl="1">
+              <a:spcAft>
+                <a:spcPts val="400"/>
+              </a:spcAft>
+              <a:defRPr sz="1300">
+                <a:solidFill>
+                  <a:srgbClr val="99BBDD"/>
+                </a:solidFill>
+                <a:latin typeface="Calibri"/>
+              </a:defRPr>
+            </a:pPr>
+            <a:r>
+              <a:t>Direct DDR quotes with well name and date</a:t>
+            </a:r>
+          </a:p>
+          <a:p>
+            <a:pPr lvl="1">
+              <a:spcAft>
+                <a:spcPts val="400"/>
+              </a:spcAft>
+              <a:defRPr sz="1300">
+                <a:solidFill>
+                  <a:srgbClr val="99BBDD"/>
+                </a:solidFill>
+                <a:latin typeface="Calibri"/>
+              </a:defRPr>
+            </a:pPr>
+            <a:r>
+              <a:t>Step-by-step reasoning chain</a:t>
+            </a:r>
+          </a:p>
+          <a:p>
+            <a:pPr lvl="1">
+              <a:spcAft>
+                <a:spcPts val="400"/>
+              </a:spcAft>
+              <a:defRPr sz="1300">
+                <a:solidFill>
+                  <a:srgbClr val="99BBDD"/>
+                </a:solidFill>
+                <a:latin typeface="Calibri"/>
+              </a:defRPr>
+            </a:pPr>
+            <a:r>
+              <a:t>Explicit assumptions and confidence level</a:t>
             </a:r>
           </a:p>
         </p:txBody>
@@ -3653,8 +3653,8 @@
         </p:nvSpPr>
         <p:spPr>
           <a:xfrm>
-            <a:off x="1097280" y="5943600"/>
-            <a:ext cx="10058400" cy="548640"/>
+            <a:off x="1371600" y="3383280"/>
+            <a:ext cx="9418320" cy="457200"/>
           </a:xfrm>
           <a:prstGeom prst="rect">
             <a:avLst/>
@@ -3667,16 +3667,155 @@
           </a:bodyPr>
           <a:lstStyle/>
           <a:p>
+            <a:pPr algn="l">
+              <a:defRPr sz="2000" b="1">
+                <a:solidFill>
+                  <a:srgbClr val="FFFFFF"/>
+                </a:solidFill>
+                <a:latin typeface="Calibri"/>
+              </a:defRPr>
+            </a:pPr>
+            <a:r>
+              <a:t>Quick Start (3 commands)</a:t>
+            </a:r>
+          </a:p>
+        </p:txBody>
+      </p:sp>
+      <p:sp>
+        <p:nvSpPr>
+          <p:cNvPr id="8" name="TextBox 7"/>
+          <p:cNvSpPr txBox="1"/>
+          <p:nvPr/>
+        </p:nvSpPr>
+        <p:spPr>
+          <a:xfrm>
+            <a:off x="1371600" y="3931920"/>
+            <a:ext cx="9418320" cy="2286000"/>
+          </a:xfrm>
+          <a:prstGeom prst="rect">
+            <a:avLst/>
+          </a:prstGeom>
+          <a:noFill/>
+        </p:spPr>
+        <p:txBody>
+          <a:bodyPr wrap="square">
+            <a:spAutoFit/>
+          </a:bodyPr>
+          <a:lstStyle/>
+          <a:p>
+            <a:pPr>
+              <a:spcAft>
+                <a:spcPts val="400"/>
+              </a:spcAft>
+              <a:defRPr sz="1500">
+                <a:solidFill>
+                  <a:srgbClr val="BBDDBB"/>
+                </a:solidFill>
+                <a:latin typeface="Calibri"/>
+              </a:defRPr>
+            </a:pPr>
+            <a:r>
+              <a:t>pip install -r requirements.txt</a:t>
+            </a:r>
+          </a:p>
+          <a:p>
+            <a:pPr>
+              <a:spcAft>
+                <a:spcPts val="400"/>
+              </a:spcAft>
+              <a:defRPr sz="1500">
+                <a:solidFill>
+                  <a:srgbClr val="BBDDBB"/>
+                </a:solidFill>
+                <a:latin typeface="Calibri"/>
+              </a:defRPr>
+            </a:pPr>
+            <a:r>
+              <a:t>python -m src.main ingest                         # ~3 minutes</a:t>
+            </a:r>
+          </a:p>
+          <a:p>
+            <a:pPr>
+              <a:spcAft>
+                <a:spcPts val="400"/>
+              </a:spcAft>
+              <a:defRPr sz="1500">
+                <a:solidFill>
+                  <a:srgbClr val="BBDDBB"/>
+                </a:solidFill>
+                <a:latin typeface="Calibri"/>
+              </a:defRPr>
+            </a:pPr>
+            <a:r>
+              <a:t>python -m src.main ask "your question"            # structured answer</a:t>
+            </a:r>
+          </a:p>
+          <a:p>
+            <a:pPr>
+              <a:spcAft>
+                <a:spcPts val="400"/>
+              </a:spcAft>
+              <a:defRPr sz="1500">
+                <a:solidFill>
+                  <a:srgbClr val="BBDDBB"/>
+                </a:solidFill>
+                <a:latin typeface="Calibri"/>
+              </a:defRPr>
+            </a:pPr>
+            <a:r>
+              <a:t>python -m src.main ask "your question" --trace    # with evidence trace</a:t>
+            </a:r>
+          </a:p>
+          <a:p>
+            <a:pPr>
+              <a:spcAft>
+                <a:spcPts val="400"/>
+              </a:spcAft>
+              <a:defRPr sz="1500">
+                <a:solidFill>
+                  <a:srgbClr val="BBDDBB"/>
+                </a:solidFill>
+                <a:latin typeface="Calibri"/>
+              </a:defRPr>
+            </a:pPr>
+            <a:r>
+              <a:t>python -m src.main demo --save                    # all 6 demo questions</a:t>
+            </a:r>
+          </a:p>
+        </p:txBody>
+      </p:sp>
+      <p:sp>
+        <p:nvSpPr>
+          <p:cNvPr id="9" name="TextBox 8"/>
+          <p:cNvSpPr txBox="1"/>
+          <p:nvPr/>
+        </p:nvSpPr>
+        <p:spPr>
+          <a:xfrm>
+            <a:off x="1097280" y="5943600"/>
+            <a:ext cx="10058400" cy="548640"/>
+          </a:xfrm>
+          <a:prstGeom prst="rect">
+            <a:avLst/>
+          </a:prstGeom>
+          <a:noFill/>
+        </p:spPr>
+        <p:txBody>
+          <a:bodyPr wrap="square">
+            <a:spAutoFit/>
+          </a:bodyPr>
+          <a:lstStyle/>
+          <a:p>
             <a:pPr algn="ctr">
-              <a:defRPr sz="1600" b="0">
-                <a:solidFill>
-                  <a:srgbClr val="D4A01E"/>
-                </a:solidFill>
-                <a:latin typeface="Calibri"/>
-              </a:defRPr>
-            </a:pPr>
-            <a:r>
-              <a:t>Clean, minimal, readable code  |  No LangChain, no framework bloat</a:t>
+              <a:defRPr sz="1400" b="0">
+                <a:solidFill>
+                  <a:srgbClr val="666666"/>
+                </a:solidFill>
+                <a:latin typeface="Calibri"/>
+              </a:defRPr>
+            </a:pPr>
+            <a:r>
+              <a:t>OPENAI_API_KEY required  |  Python 3.10+  |  Volve dataset in .googledrive/</a:t>
             </a:r>
           </a:p>
         </p:txBody>
@@ -4334,7 +4473,7 @@
               </a:defRPr>
             </a:pPr>
             <a:r>
-              <a:t>Pure OpenAI SDK + DuckDB + ChromaDB  |  No LangChain, no framework bloat</a:t>
+              <a:t>OpenAI SDK  +  DuckDB  +  ChromaDB</a:t>
             </a:r>
           </a:p>
         </p:txBody>
@@ -6426,7 +6565,7 @@
               </a:defRPr>
             </a:pPr>
             <a:r>
-              <a:t>Key Differentiators</a:t>
+              <a:t>How Evidence is Gathered</a:t>
             </a:r>
           </a:p>
         </p:txBody>
@@ -6465,7 +6604,7 @@
               </a:defRPr>
             </a:pPr>
             <a:r>
-              <a:t>WITSML mudlog = actual measured ROP/WOB/RPM</a:t>
+              <a:t>Structured data: WITSML mudlog provides actual</a:t>
             </a:r>
           </a:p>
           <a:p>
@@ -6481,7 +6620,7 @@
               </a:defRPr>
             </a:pPr>
             <a:r>
-              <a:t>(not estimated from daily depth progress)</a:t>
+              <a:t>measured ROP, WOB, RPM per depth interval</a:t>
             </a:r>
           </a:p>
           <a:p>
@@ -6510,7 +6649,7 @@
               </a:defRPr>
             </a:pPr>
             <a:r>
-              <a:t>Hole-size transitions define phases</a:t>
+              <a:t>Drilling phases: identified by hole-size</a:t>
             </a:r>
           </a:p>
           <a:p>
@@ -6526,7 +6665,7 @@
               </a:defRPr>
             </a:pPr>
             <a:r>
-              <a:t>(not just generic activity code classification)</a:t>
+              <a:t>transitions and validated against DDR text</a:t>
             </a:r>
           </a:p>
           <a:p>
@@ -6555,7 +6694,7 @@
               </a:defRPr>
             </a:pPr>
             <a:r>
-              <a:t>Formation context links ROP to geology</a:t>
+              <a:t>Formation context: ROP variations correlated</a:t>
             </a:r>
           </a:p>
           <a:p>
@@ -6571,7 +6710,7 @@
               </a:defRPr>
             </a:pPr>
             <a:r>
-              <a:t>(why is this section slow? check the lithology)</a:t>
+              <a:t>with lithology from mudlog + formation tops</a:t>
             </a:r>
           </a:p>
           <a:p>
@@ -6600,7 +6739,7 @@
               </a:defRPr>
             </a:pPr>
             <a:r>
-              <a:t>Statistical mud-problem correlation</a:t>
+              <a:t>Mud-problem analysis: statistical comparison</a:t>
             </a:r>
           </a:p>
           <a:p>
@@ -6616,7 +6755,7 @@
               </a:defRPr>
             </a:pPr>
             <a:r>
-              <a:t>(problem-day vs normal-day property comparison)</a:t>
+              <a:t>of mud properties on problem vs normal days</a:t>
             </a:r>
           </a:p>
           <a:p>
@@ -6645,7 +6784,7 @@
               </a:defRPr>
             </a:pPr>
             <a:r>
-              <a:t>NPT sub-classified by comment analysis</a:t>
+              <a:t>NPT decomposition: 11 sub-categories derived</a:t>
             </a:r>
           </a:p>
           <a:p>
@@ -6661,7 +6800,7 @@
               </a:defRPr>
             </a:pPr>
             <a:r>
-              <a:t>(11 categories instead of generic 'Other NPT')</a:t>
+              <a:t>from comment text analysis (not just activity codes)</a:t>
             </a:r>
           </a:p>
         </p:txBody>
@@ -8141,7 +8280,7 @@
               </a:defRPr>
             </a:pPr>
             <a:r>
-              <a:t>python -m src.main ask '...' --trace   |   Turns the black box into a glass box</a:t>
+              <a:t>python -m src.main ask '...' --trace</a:t>
             </a:r>
           </a:p>
         </p:txBody>
@@ -8375,7 +8514,7 @@
           <a:lstStyle/>
           <a:p>
             <a:pPr algn="l">
-              <a:defRPr sz="1600" b="1">
+              <a:defRPr sz="1500" b="0">
                 <a:solidFill>
                   <a:srgbClr val="007B83"/>
                 </a:solidFill>
@@ -8383,7 +8522,7 @@
               </a:defRPr>
             </a:pPr>
             <a:r>
-              <a:t>Judges can see EXACTLY how the agent reasoned. Maximum transparency.</a:t>
+              <a:t>Each tool call, its arguments, result size, and execution time are logged for full traceability.</a:t>
             </a:r>
           </a:p>
         </p:txBody>
@@ -8559,7 +8698,7 @@
               </a:defRPr>
             </a:pPr>
             <a:r>
-              <a:t>"Complexity alone will not be rewarded" -- Judges</a:t>
+              <a:t>Prioritizing simplicity, transparency, and reproducibility</a:t>
             </a:r>
           </a:p>
         </p:txBody>
@@ -8598,7 +8737,7 @@
               </a:defRPr>
             </a:pPr>
             <a:r>
-              <a:t>OpenAI SDK over LangChain</a:t>
+              <a:t>Technology Choices</a:t>
             </a:r>
           </a:p>
           <a:p>
@@ -8614,7 +8753,55 @@
               </a:defRPr>
             </a:pPr>
             <a:r>
-              <a:t>Transparent, debuggable, minimal dependencies</a:t>
+              <a:t>OpenAI SDK: direct function calling, minimal abstraction</a:t>
+            </a:r>
+          </a:p>
+          <a:p>
+            <a:pPr lvl="1">
+              <a:spcAft>
+                <a:spcPts val="400"/>
+              </a:spcAft>
+              <a:defRPr sz="1300">
+                <a:solidFill>
+                  <a:srgbClr val="666666"/>
+                </a:solidFill>
+                <a:latin typeface="Calibri"/>
+              </a:defRPr>
+            </a:pPr>
+            <a:r>
+              <a:t>DuckDB: in-process analytical SQL, zero configuration</a:t>
+            </a:r>
+          </a:p>
+          <a:p>
+            <a:pPr lvl="1">
+              <a:spcAft>
+                <a:spcPts val="400"/>
+              </a:spcAft>
+              <a:defRPr sz="1300">
+                <a:solidFill>
+                  <a:srgbClr val="666666"/>
+                </a:solidFill>
+                <a:latin typeface="Calibri"/>
+              </a:defRPr>
+            </a:pPr>
+            <a:r>
+              <a:t>ChromaDB: embedded vector search, cosine similarity</a:t>
+            </a:r>
+          </a:p>
+          <a:p>
+            <a:pPr lvl="1">
+              <a:spcAft>
+                <a:spcPts val="400"/>
+              </a:spcAft>
+              <a:defRPr sz="1300">
+                <a:solidFill>
+                  <a:srgbClr val="666666"/>
+                </a:solidFill>
+                <a:latin typeface="Calibri"/>
+              </a:defRPr>
+            </a:pPr>
+            <a:r>
+              <a:t>GPT-5.4 mini: reasoning_effort=high for domain questions</a:t>
             </a:r>
           </a:p>
           <a:p>
@@ -8643,7 +8830,7 @@
               </a:defRPr>
             </a:pPr>
             <a:r>
-              <a:t>DuckDB over SQLite / Postgres</a:t>
+              <a:t>Phase Detection Approach</a:t>
             </a:r>
           </a:p>
           <a:p>
@@ -8659,36 +8846,7 @@
               </a:defRPr>
             </a:pPr>
             <a:r>
-              <a:t>In-process analytical SQL, zero config, fast</a:t>
-            </a:r>
-          </a:p>
-          <a:p>
-            <a:pPr>
-              <a:spcAft>
-                <a:spcPts val="400"/>
-              </a:spcAft>
-              <a:defRPr sz="1400">
-                <a:solidFill>
-                  <a:srgbClr val="1A1A1A"/>
-                </a:solidFill>
-                <a:latin typeface="Calibri"/>
-              </a:defRPr>
-            </a:pPr>
-          </a:p>
-          <a:p>
-            <a:pPr>
-              <a:spcAft>
-                <a:spcPts val="400"/>
-              </a:spcAft>
-              <a:defRPr sz="1400">
-                <a:solidFill>
-                  <a:srgbClr val="1A1A1A"/>
-                </a:solidFill>
-                <a:latin typeface="Calibri"/>
-              </a:defRPr>
-            </a:pPr>
-            <a:r>
-              <a:t>ChromaDB for semantic retrieval</a:t>
+              <a:t>Rule-based: hole sizes + activity codes (deterministic)</a:t>
             </a:r>
           </a:p>
           <a:p>
@@ -8704,36 +8862,7 @@
               </a:defRPr>
             </a:pPr>
             <a:r>
-              <a:t>Lightweight, embedded, cosine similarity</a:t>
-            </a:r>
-          </a:p>
-          <a:p>
-            <a:pPr>
-              <a:spcAft>
-                <a:spcPts val="400"/>
-              </a:spcAft>
-              <a:defRPr sz="1400">
-                <a:solidFill>
-                  <a:srgbClr val="1A1A1A"/>
-                </a:solidFill>
-                <a:latin typeface="Calibri"/>
-              </a:defRPr>
-            </a:pPr>
-          </a:p>
-          <a:p>
-            <a:pPr>
-              <a:spcAft>
-                <a:spcPts val="400"/>
-              </a:spcAft>
-              <a:defRPr sz="1400">
-                <a:solidFill>
-                  <a:srgbClr val="1A1A1A"/>
-                </a:solidFill>
-                <a:latin typeface="Calibri"/>
-              </a:defRPr>
-            </a:pPr>
-            <a:r>
-              <a:t>GPT-5.4 mini configured for reasoning_effort=high</a:t>
+              <a:t>LLM: validates against DDR narratives, handles ambiguity</a:t>
             </a:r>
           </a:p>
           <a:p>
@@ -8749,23 +8878,7 @@
               </a:defRPr>
             </a:pPr>
             <a:r>
-              <a:t>Best reasoning quality for drilling domain</a:t>
-            </a:r>
-          </a:p>
-          <a:p>
-            <a:pPr lvl="1">
-              <a:spcAft>
-                <a:spcPts val="400"/>
-              </a:spcAft>
-              <a:defRPr sz="1300">
-                <a:solidFill>
-                  <a:srgbClr val="666666"/>
-                </a:solidFill>
-                <a:latin typeface="Calibri"/>
-              </a:defRPr>
-            </a:pPr>
-            <a:r>
-              <a:t>Graceful runtime fallback when unsupported</a:t>
+              <a:t>Confidence: assessed per answer (HIGH / MEDIUM / LOW)</a:t>
             </a:r>
           </a:p>
         </p:txBody>
@@ -8804,7 +8917,7 @@
               </a:defRPr>
             </a:pPr>
             <a:r>
-              <a:t>Rule-based + LLM hybrid for phase detection</a:t>
+              <a:t>Tool Design Philosophy</a:t>
             </a:r>
           </a:p>
           <a:p>
@@ -8820,7 +8933,7 @@
               </a:defRPr>
             </a:pPr>
             <a:r>
-              <a:t>Rules: hole sizes + activity codes (deterministic)</a:t>
+              <a:t>Each tool built for a specific question category</a:t>
             </a:r>
           </a:p>
           <a:p>
@@ -8836,7 +8949,23 @@
               </a:defRPr>
             </a:pPr>
             <a:r>
-              <a:t>LLM: validates against DDR narratives</a:t>
+              <a:t>Tools return structured evidence with source attribution</a:t>
+            </a:r>
+          </a:p>
+          <a:p>
+            <a:pPr lvl="1">
+              <a:spcAft>
+                <a:spcPts val="400"/>
+              </a:spcAft>
+              <a:defRPr sz="1300">
+                <a:solidFill>
+                  <a:srgbClr val="666666"/>
+                </a:solidFill>
+                <a:latin typeface="Calibri"/>
+              </a:defRPr>
+            </a:pPr>
+            <a:r>
+              <a:t>12 tools covering all 6 evaluation categories</a:t>
             </a:r>
           </a:p>
           <a:p>
@@ -8865,7 +8994,7 @@
               </a:defRPr>
             </a:pPr>
             <a:r>
-              <a:t>Domain-specific tooling over generic agents</a:t>
+              <a:t>Quality Assurance</a:t>
             </a:r>
           </a:p>
           <a:p>
@@ -8881,7 +9010,7 @@
               </a:defRPr>
             </a:pPr>
             <a:r>
-              <a:t>Each tool purpose-built for a question category</a:t>
+              <a:t>95 automated unit tests (parsers, tools, formatting)</a:t>
             </a:r>
           </a:p>
           <a:p>
@@ -8897,36 +9026,7 @@
               </a:defRPr>
             </a:pPr>
             <a:r>
-              <a:t>Tools return structured evidence, not raw data</a:t>
-            </a:r>
-          </a:p>
-          <a:p>
-            <a:pPr>
-              <a:spcAft>
-                <a:spcPts val="400"/>
-              </a:spcAft>
-              <a:defRPr sz="1400">
-                <a:solidFill>
-                  <a:srgbClr val="1A1A1A"/>
-                </a:solidFill>
-                <a:latin typeface="Calibri"/>
-              </a:defRPr>
-            </a:pPr>
-          </a:p>
-          <a:p>
-            <a:pPr>
-              <a:spcAft>
-                <a:spcPts val="400"/>
-              </a:spcAft>
-              <a:defRPr sz="1400">
-                <a:solidFill>
-                  <a:srgbClr val="1A1A1A"/>
-                </a:solidFill>
-                <a:latin typeface="Calibri"/>
-              </a:defRPr>
-            </a:pPr>
-            <a:r>
-              <a:t>Quality assurance</a:t>
+              <a:t>130-question stress test across diverse wells &amp; categories</a:t>
             </a:r>
           </a:p>
           <a:p>
@@ -8942,7 +9042,7 @@
               </a:defRPr>
             </a:pPr>
             <a:r>
-              <a:t>95 automated tests, 130-question primary stress test</a:t>
+              <a:t>Output validation checks all 6 required answer sections</a:t>
             </a:r>
           </a:p>
           <a:p>
@@ -8958,7 +9058,7 @@
               </a:defRPr>
             </a:pPr>
             <a:r>
-              <a:t>Baseline avg 7.59/10 -&gt; 8.02/10 after fixes</a:t>
+              <a:t>Data quality filtering at ingestion and query time</a:t>
             </a:r>
           </a:p>
           <a:p>
@@ -8974,23 +9074,7 @@
               </a:defRPr>
             </a:pPr>
             <a:r>
-              <a:t>Output validation checks all 6 answer sections</a:t>
-            </a:r>
-          </a:p>
-          <a:p>
-            <a:pPr lvl="1">
-              <a:spcAft>
-                <a:spcPts val="400"/>
-              </a:spcAft>
-              <a:defRPr sz="1300">
-                <a:solidFill>
-                  <a:srgbClr val="666666"/>
-                </a:solidFill>
-                <a:latin typeface="Calibri"/>
-              </a:defRPr>
-            </a:pPr>
-            <a:r>
-              <a:t>Data quality filtering at ingestion + query time</a:t>
+              <a:t>Sentinel value handling, outlier removal, unit conversions</a:t>
             </a:r>
           </a:p>
         </p:txBody>

</xml_diff>

<commit_message>
feat: Add initial presentation slides.
</commit_message>
<xml_diff>
--- a/presentation/slides.pptx
+++ b/presentation/slides.pptx
@@ -4,6 +4,9 @@
   <p:sldMasterIdLst>
     <p:sldMasterId id="2147483648" r:id="rId1"/>
   </p:sldMasterIdLst>
+  <p:notesMasterIdLst>
+    <p:notesMasterId r:id="rId12"/>
+  </p:notesMasterIdLst>
   <p:sldIdLst>
     <p:sldId id="256" r:id="rId2"/>
     <p:sldId id="257" r:id="rId3"/>
@@ -16,10 +19,7 @@
     <p:sldId id="264" r:id="rId10"/>
     <p:sldId id="265" r:id="rId11"/>
   </p:sldIdLst>
-  <p:notesMasterIdLst>
-    <p:notesMasterId r:id="rId12"/>
-  </p:notesMasterIdLst>
-  <p:sldSz cx="9144000" cy="5143500"/>
+  <p:sldSz cx="9144000" cy="5143500" type="screen16x9"/>
   <p:notesSz cx="5143500" cy="9144000"/>
   <p:defaultTextStyle>
     <a:lvl1pPr marL="0" algn="l" defTabSz="914400" rtl="0" eaLnBrk="1" latinLnBrk="0" hangingPunct="1">
@@ -113,13 +113,20 @@
       </a:defRPr>
     </a:lvl9pPr>
   </p:defaultTextStyle>
+  <p:extLst>
+    <p:ext uri="{EFAFB233-063F-42B5-8137-9DF3F51BA10A}">
+      <p15:sldGuideLst xmlns:p15="http://schemas.microsoft.com/office/powerpoint/2012/main"/>
+    </p:ext>
+  </p:extLst>
 </p:presentation>
 </file>
 
 <file path=ppt/charts/chart1.xml><?xml version="1.0" encoding="utf-8"?>
-<c:chartSpace xmlns:c="http://schemas.openxmlformats.org/drawingml/2006/chart" xmlns:a="http://schemas.openxmlformats.org/drawingml/2006/main" xmlns:r="http://schemas.openxmlformats.org/officeDocument/2006/relationships">
+<c:chartSpace xmlns:c="http://schemas.openxmlformats.org/drawingml/2006/chart" xmlns:a="http://schemas.openxmlformats.org/drawingml/2006/main" xmlns:r="http://schemas.openxmlformats.org/officeDocument/2006/relationships" xmlns:c16r2="http://schemas.microsoft.com/office/drawing/2015/06/chart">
   <c:date1904 val="0"/>
+  <c:lang val="en-US"/>
   <c:roundedCorners val="0"/>
+  <c:style val="2"/>
   <c:chart>
     <c:autoTitleDeleted val="1"/>
     <c:plotArea>
@@ -151,18 +158,26 @@
           <c:invertIfNegative val="0"/>
           <c:dLbls>
             <c:numFmt formatCode="#,##0" sourceLinked="0"/>
+            <c:spPr>
+              <a:noFill/>
+              <a:ln>
+                <a:noFill/>
+              </a:ln>
+              <a:effectLst/>
+            </c:spPr>
             <c:txPr>
               <a:bodyPr/>
               <a:lstStyle/>
               <a:p>
                 <a:pPr>
-                  <a:defRPr b="0" i="0" strike="noStrike" sz="800" u="none">
+                  <a:defRPr sz="800" b="0" i="0" u="none" strike="noStrike">
                     <a:solidFill>
                       <a:srgbClr val="1E293B"/>
                     </a:solidFill>
                     <a:latin typeface="Arial"/>
                   </a:defRPr>
                 </a:pPr>
+                <a:endParaRPr lang="en-US"/>
               </a:p>
             </c:txPr>
             <c:showLegendKey val="0"/>
@@ -172,46 +187,49 @@
             <c:showPercent val="0"/>
             <c:showBubbleSize val="0"/>
             <c:showLeaderLines val="0"/>
+            <c:extLst>
+              <c:ext xmlns:c15="http://schemas.microsoft.com/office/drawing/2012/chart" uri="{CE6537A1-D6FC-4f65-9D91-7224C49458BB}">
+                <c15:showLeaderLines val="0"/>
+              </c:ext>
+            </c:extLst>
           </c:dLbls>
           <c:cat>
-            <c:multiLvlStrRef>
+            <c:strRef>
               <c:f>Sheet1!$A$2:$A$11</c:f>
-              <c:multiLvlStrCache>
+              <c:strCache>
                 <c:ptCount val="10"/>
-                <c:lvl>
-                  <c:pt idx="0">
-                    <c:v>DDR Activities</c:v>
-                  </c:pt>
-                  <c:pt idx="1">
-                    <c:v>Production</c:v>
-                  </c:pt>
-                  <c:pt idx="2">
-                    <c:v>WITSML Msgs</c:v>
-                  </c:pt>
-                  <c:pt idx="3">
-                    <c:v>Trajectory</c:v>
-                  </c:pt>
-                  <c:pt idx="4">
-                    <c:v>MudLog</c:v>
-                  </c:pt>
-                  <c:pt idx="5">
-                    <c:v>BHA Runs</c:v>
-                  </c:pt>
-                  <c:pt idx="6">
-                    <c:v>Fluids</c:v>
-                  </c:pt>
-                  <c:pt idx="7">
-                    <c:v>Surveys</c:v>
-                  </c:pt>
-                  <c:pt idx="8">
-                    <c:v>Form. Tops</c:v>
-                  </c:pt>
-                  <c:pt idx="9">
-                    <c:v>Perforations</c:v>
-                  </c:pt>
-                </c:lvl>
-              </c:multiLvlStrCache>
-            </c:multiLvlStrRef>
+                <c:pt idx="0">
+                  <c:v>DDR Activities</c:v>
+                </c:pt>
+                <c:pt idx="1">
+                  <c:v>Production</c:v>
+                </c:pt>
+                <c:pt idx="2">
+                  <c:v>WITSML Msgs</c:v>
+                </c:pt>
+                <c:pt idx="3">
+                  <c:v>Trajectory</c:v>
+                </c:pt>
+                <c:pt idx="4">
+                  <c:v>MudLog</c:v>
+                </c:pt>
+                <c:pt idx="5">
+                  <c:v>BHA Runs</c:v>
+                </c:pt>
+                <c:pt idx="6">
+                  <c:v>Fluids</c:v>
+                </c:pt>
+                <c:pt idx="7">
+                  <c:v>Surveys</c:v>
+                </c:pt>
+                <c:pt idx="8">
+                  <c:v>Form. Tops</c:v>
+                </c:pt>
+                <c:pt idx="9">
+                  <c:v>Perforations</c:v>
+                </c:pt>
+              </c:strCache>
+            </c:strRef>
           </c:cat>
           <c:val>
             <c:numRef>
@@ -252,36 +270,23 @@
               </c:numCache>
             </c:numRef>
           </c:val>
+          <c:extLst>
+            <c:ext xmlns:c16="http://schemas.microsoft.com/office/drawing/2014/chart" uri="{C3380CC4-5D6E-409C-BE32-E72D297353CC}">
+              <c16:uniqueId val="{00000000-36B6-4B75-89B2-4FDB3FD0AFC3}"/>
+            </c:ext>
+          </c:extLst>
         </c:ser>
         <c:dLbls>
-          <c:numFmt formatCode="#,##0" sourceLinked="0"/>
-          <c:txPr>
-            <a:bodyPr/>
-            <a:lstStyle/>
-            <a:p>
-              <a:pPr>
-                <a:defRPr b="0" i="0" strike="noStrike" sz="800" u="none">
-                  <a:solidFill>
-                    <a:srgbClr val="1E293B"/>
-                  </a:solidFill>
-                  <a:latin typeface="Arial"/>
-                </a:defRPr>
-              </a:pPr>
-            </a:p>
-          </c:txPr>
           <c:showLegendKey val="0"/>
           <c:showVal val="1"/>
           <c:showCatName val="0"/>
           <c:showSerName val="0"/>
           <c:showPercent val="0"/>
           <c:showBubbleSize val="0"/>
-          <c:showLeaderLines val="0"/>
         </c:dLbls>
         <c:gapWidth val="150"/>
-        <c:overlap val="0"/>
         <c:axId val="2094734554"/>
         <c:axId val="2094734552"/>
-        <c:axId val="2094734556"/>
       </c:barChart>
       <c:catAx>
         <c:axId val="2094734554"/>
@@ -322,6 +327,7 @@
         <c:crosses val="autoZero"/>
         <c:auto val="1"/>
         <c:lblAlgn val="ctr"/>
+        <c:lblOffset val="100"/>
         <c:noMultiLvlLbl val="1"/>
       </c:catAx>
       <c:valAx>
@@ -384,6 +390,7 @@
     </c:plotArea>
     <c:plotVisOnly val="1"/>
     <c:dispBlanksAs val="span"/>
+    <c:showDLblsOverMax val="1"/>
   </c:chart>
   <c:spPr>
     <a:solidFill>
@@ -422,234 +429,10 @@
           <a:chExt cx="0" cy="0"/>
         </a:xfrm>
       </p:grpSpPr>
-      <p:sp>
-        <p:nvSpPr>
-          <p:cNvPr id="2" name="Header Placeholder 1"/>
-          <p:cNvSpPr>
-            <a:spLocks noGrp="1"/>
-          </p:cNvSpPr>
-          <p:nvPr>
-            <p:ph type="hdr" sz="quarter"/>
-          </p:nvPr>
-        </p:nvSpPr>
-        <p:spPr>
-          <a:xfrm>
-            <a:off x="0" y="0"/>
-            <a:ext cx="2971800" cy="458788"/>
-          </a:xfrm>
-          <a:prstGeom prst="rect">
-            <a:avLst/>
-          </a:prstGeom>
-        </p:spPr>
-        <p:txBody>
-          <a:bodyPr vert="horz" lIns="91440" tIns="45720" rIns="91440" bIns="45720" rtlCol="0"/>
-          <a:lstStyle>
-            <a:lvl1pPr algn="l">
-              <a:defRPr sz="1200"/>
-            </a:lvl1pPr>
-          </a:lstStyle>
-          <a:p>
-            <a:endParaRPr lang="en-US"/>
-          </a:p>
-        </p:txBody>
-      </p:sp>
-      <p:sp>
-        <p:nvSpPr>
-          <p:cNvPr id="3" name="Date Placeholder 2"/>
-          <p:cNvSpPr>
-            <a:spLocks noGrp="1"/>
-          </p:cNvSpPr>
-          <p:nvPr>
-            <p:ph type="dt" idx="1"/>
-          </p:nvPr>
-        </p:nvSpPr>
-        <p:spPr>
-          <a:xfrm>
-            <a:off x="3884613" y="0"/>
-            <a:ext cx="2971800" cy="458788"/>
-          </a:xfrm>
-          <a:prstGeom prst="rect">
-            <a:avLst/>
-          </a:prstGeom>
-        </p:spPr>
-        <p:txBody>
-          <a:bodyPr vert="horz" lIns="91440" tIns="45720" rIns="91440" bIns="45720" rtlCol="0"/>
-          <a:lstStyle>
-            <a:lvl1pPr algn="r">
-              <a:defRPr sz="1200"/>
-            </a:lvl1pPr>
-          </a:lstStyle>
-          <a:p>
-            <a:fld id="{5282F153-3F37-0F45-9E97-73ACFA13230C}" type="datetimeFigureOut">
-              <a:rPr lang="en-US"/>
-              <a:t>7/23/19</a:t>
-            </a:fld>
-            <a:endParaRPr lang="en-US"/>
-          </a:p>
-        </p:txBody>
-      </p:sp>
-      <p:sp>
-        <p:nvSpPr>
-          <p:cNvPr id="4" name="Slide Image Placeholder 3"/>
-          <p:cNvSpPr>
-            <a:spLocks noGrp="1" noRot="1" noChangeAspect="1"/>
-          </p:cNvSpPr>
-          <p:nvPr>
-            <p:ph type="sldImg" idx="2"/>
-          </p:nvPr>
-        </p:nvSpPr>
-        <p:spPr>
-          <a:xfrm>
-            <a:off x="685800" y="1143000"/>
-            <a:ext cx="5486400" cy="3086100"/>
-          </a:xfrm>
-          <a:prstGeom prst="rect">
-            <a:avLst/>
-          </a:prstGeom>
-          <a:noFill/>
-          <a:ln w="12700">
-            <a:solidFill>
-              <a:prstClr val="black"/>
-            </a:solidFill>
-          </a:ln>
-        </p:spPr>
-        <p:txBody>
-          <a:bodyPr vert="horz" lIns="91440" tIns="45720" rIns="91440" bIns="45720" rtlCol="0" anchor="ctr"/>
-          <a:lstStyle/>
-          <a:p>
-            <a:endParaRPr lang="en-US"/>
-          </a:p>
-        </p:txBody>
-      </p:sp>
-      <p:sp>
-        <p:nvSpPr>
-          <p:cNvPr id="5" name="Notes Placeholder 4"/>
-          <p:cNvSpPr>
-            <a:spLocks noGrp="1"/>
-          </p:cNvSpPr>
-          <p:nvPr>
-            <p:ph type="body" sz="quarter" idx="3"/>
-          </p:nvPr>
-        </p:nvSpPr>
-        <p:spPr>
-          <a:xfrm>
-            <a:off x="685800" y="4400550"/>
-            <a:ext cx="5486400" cy="3600450"/>
-          </a:xfrm>
-          <a:prstGeom prst="rect">
-            <a:avLst/>
-          </a:prstGeom>
-        </p:spPr>
-        <p:txBody>
-          <a:bodyPr vert="horz" lIns="91440" tIns="45720" rIns="91440" bIns="45720" rtlCol="0"/>
-          <a:lstStyle/>
-          <a:p>
-            <a:pPr lvl="0"/>
-            <a:r>
-              <a:rPr lang="en-US"/>
-              <a:t>Click to edit Master text styles</a:t>
-            </a:r>
-          </a:p>
-          <a:p>
-            <a:pPr lvl="1"/>
-            <a:r>
-              <a:rPr lang="en-US"/>
-              <a:t>Second level</a:t>
-            </a:r>
-          </a:p>
-          <a:p>
-            <a:pPr lvl="2"/>
-            <a:r>
-              <a:rPr lang="en-US"/>
-              <a:t>Third level</a:t>
-            </a:r>
-          </a:p>
-          <a:p>
-            <a:pPr lvl="3"/>
-            <a:r>
-              <a:rPr lang="en-US"/>
-              <a:t>Fourth level</a:t>
-            </a:r>
-          </a:p>
-          <a:p>
-            <a:pPr lvl="4"/>
-            <a:r>
-              <a:rPr lang="en-US"/>
-              <a:t>Fifth level</a:t>
-            </a:r>
-          </a:p>
-        </p:txBody>
-      </p:sp>
-      <p:sp>
-        <p:nvSpPr>
-          <p:cNvPr id="6" name="Footer Placeholder 5"/>
-          <p:cNvSpPr>
-            <a:spLocks noGrp="1"/>
-          </p:cNvSpPr>
-          <p:nvPr>
-            <p:ph type="ftr" sz="quarter" idx="4"/>
-          </p:nvPr>
-        </p:nvSpPr>
-        <p:spPr>
-          <a:xfrm>
-            <a:off x="0" y="8685213"/>
-            <a:ext cx="2971800" cy="458787"/>
-          </a:xfrm>
-          <a:prstGeom prst="rect">
-            <a:avLst/>
-          </a:prstGeom>
-        </p:spPr>
-        <p:txBody>
-          <a:bodyPr vert="horz" lIns="91440" tIns="45720" rIns="91440" bIns="45720" rtlCol="0" anchor="b"/>
-          <a:lstStyle>
-            <a:lvl1pPr algn="l">
-              <a:defRPr sz="1200"/>
-            </a:lvl1pPr>
-          </a:lstStyle>
-          <a:p>
-            <a:endParaRPr lang="en-US"/>
-          </a:p>
-        </p:txBody>
-      </p:sp>
-      <p:sp>
-        <p:nvSpPr>
-          <p:cNvPr id="7" name="Slide Number Placeholder 6"/>
-          <p:cNvSpPr>
-            <a:spLocks noGrp="1"/>
-          </p:cNvSpPr>
-          <p:nvPr>
-            <p:ph type="sldNum" sz="quarter" idx="5"/>
-          </p:nvPr>
-        </p:nvSpPr>
-        <p:spPr>
-          <a:xfrm>
-            <a:off x="3884613" y="8685213"/>
-            <a:ext cx="2971800" cy="458787"/>
-          </a:xfrm>
-          <a:prstGeom prst="rect">
-            <a:avLst/>
-          </a:prstGeom>
-        </p:spPr>
-        <p:txBody>
-          <a:bodyPr vert="horz" lIns="91440" tIns="45720" rIns="91440" bIns="45720" rtlCol="0" anchor="b"/>
-          <a:lstStyle>
-            <a:lvl1pPr algn="r">
-              <a:defRPr sz="1200"/>
-            </a:lvl1pPr>
-          </a:lstStyle>
-          <a:p>
-            <a:fld id="{CE5E9CC1-C706-0F49-92D6-E571CC5EEA8F}" type="slidenum">
-              <a:rPr lang="en-US"/>
-              <a:t>‹#›</a:t>
-            </a:fld>
-            <a:endParaRPr lang="en-US"/>
-          </a:p>
-        </p:txBody>
-      </p:sp>
     </p:spTree>
     <p:extLst>
       <p:ext uri="{BB962C8B-B14F-4D97-AF65-F5344CB8AC3E}">
-        <p14:creationId xmlns:p14="http://schemas.microsoft.com/office/powerpoint/2010/main" val="1024086991"/>
+        <p14:creationId xmlns:p14="http://schemas.microsoft.com/office/powerpoint/2010/main" val="3307723132"/>
       </p:ext>
     </p:extLst>
   </p:cSld>
@@ -793,10 +576,6 @@
           <a:bodyPr/>
           <a:lstStyle/>
           <a:p>
-            <a:r>
-              <a:rPr lang="en-US" dirty="0"/>
-              <a:t/>
-            </a:r>
             <a:endParaRPr lang="en-US" dirty="0"/>
           </a:p>
         </p:txBody>
@@ -881,10 +660,6 @@
           <a:bodyPr/>
           <a:lstStyle/>
           <a:p>
-            <a:r>
-              <a:rPr lang="en-US" dirty="0"/>
-              <a:t/>
-            </a:r>
             <a:endParaRPr lang="en-US" dirty="0"/>
           </a:p>
         </p:txBody>
@@ -969,10 +744,6 @@
           <a:bodyPr/>
           <a:lstStyle/>
           <a:p>
-            <a:r>
-              <a:rPr lang="en-US" dirty="0"/>
-              <a:t/>
-            </a:r>
             <a:endParaRPr lang="en-US" dirty="0"/>
           </a:p>
         </p:txBody>
@@ -1057,10 +828,6 @@
           <a:bodyPr/>
           <a:lstStyle/>
           <a:p>
-            <a:r>
-              <a:rPr lang="en-US" dirty="0"/>
-              <a:t/>
-            </a:r>
             <a:endParaRPr lang="en-US" dirty="0"/>
           </a:p>
         </p:txBody>
@@ -1145,10 +912,6 @@
           <a:bodyPr/>
           <a:lstStyle/>
           <a:p>
-            <a:r>
-              <a:rPr lang="en-US" dirty="0"/>
-              <a:t/>
-            </a:r>
             <a:endParaRPr lang="en-US" dirty="0"/>
           </a:p>
         </p:txBody>
@@ -1233,10 +996,6 @@
           <a:bodyPr/>
           <a:lstStyle/>
           <a:p>
-            <a:r>
-              <a:rPr lang="en-US" dirty="0"/>
-              <a:t/>
-            </a:r>
             <a:endParaRPr lang="en-US" dirty="0"/>
           </a:p>
         </p:txBody>
@@ -1321,10 +1080,6 @@
           <a:bodyPr/>
           <a:lstStyle/>
           <a:p>
-            <a:r>
-              <a:rPr lang="en-US" dirty="0"/>
-              <a:t/>
-            </a:r>
             <a:endParaRPr lang="en-US" dirty="0"/>
           </a:p>
         </p:txBody>
@@ -1409,10 +1164,6 @@
           <a:bodyPr/>
           <a:lstStyle/>
           <a:p>
-            <a:r>
-              <a:rPr lang="en-US" dirty="0"/>
-              <a:t/>
-            </a:r>
             <a:endParaRPr lang="en-US" dirty="0"/>
           </a:p>
         </p:txBody>
@@ -1497,10 +1248,6 @@
           <a:bodyPr/>
           <a:lstStyle/>
           <a:p>
-            <a:r>
-              <a:rPr lang="en-US" dirty="0"/>
-              <a:t/>
-            </a:r>
             <a:endParaRPr lang="en-US" dirty="0"/>
           </a:p>
         </p:txBody>
@@ -1585,10 +1332,6 @@
           <a:bodyPr/>
           <a:lstStyle/>
           <a:p>
-            <a:r>
-              <a:rPr lang="en-US" dirty="0"/>
-              <a:t/>
-            </a:r>
             <a:endParaRPr lang="en-US" dirty="0"/>
           </a:p>
         </p:txBody>
@@ -1662,6 +1405,11 @@
 <file path=ppt/slideMasters/slideMaster1.xml><?xml version="1.0" encoding="utf-8"?>
 <p:sldMaster xmlns:a="http://schemas.openxmlformats.org/drawingml/2006/main" xmlns:r="http://schemas.openxmlformats.org/officeDocument/2006/relationships" xmlns:p="http://schemas.openxmlformats.org/presentationml/2006/main">
   <p:cSld>
+    <p:bg>
+      <p:bgRef idx="1001">
+        <a:schemeClr val="bg1"/>
+      </p:bgRef>
+    </p:bg>
     <p:spTree>
       <p:nvGrpSpPr>
         <p:cNvPr id="1" name=""/>
@@ -1944,6 +1692,7 @@
         <a:solidFill>
           <a:srgbClr val="1B2A4A"/>
         </a:solidFill>
+        <a:effectLst/>
       </p:bgPr>
     </p:bg>
     <p:spTree>
@@ -2001,7 +1750,7 @@
           <a:bodyPr wrap="square" lIns="0" tIns="0" rIns="0" bIns="0" rtlCol="0" anchor="ctr"/>
           <a:lstStyle/>
           <a:p>
-            <a:pPr indent="0" marL="0">
+            <a:pPr marL="0" indent="0">
               <a:lnSpc>
                 <a:spcPct val="110000"/>
               </a:lnSpc>
@@ -2021,7 +1770,7 @@
             <a:endParaRPr lang="en-US" sz="4000" dirty="0"/>
           </a:p>
           <a:p>
-            <a:pPr indent="0" marL="0">
+            <a:pPr marL="0" indent="0">
               <a:lnSpc>
                 <a:spcPct val="110000"/>
               </a:lnSpc>
@@ -2083,7 +1832,7 @@
           <a:bodyPr wrap="square" lIns="0" tIns="0" rIns="0" bIns="0" rtlCol="0" anchor="ctr"/>
           <a:lstStyle/>
           <a:p>
-            <a:pPr indent="0" marL="0">
+            <a:pPr marL="0" indent="0">
               <a:lnSpc>
                 <a:spcPct val="130000"/>
               </a:lnSpc>
@@ -2103,7 +1852,7 @@
             <a:endParaRPr lang="en-US" sz="1600" dirty="0"/>
           </a:p>
           <a:p>
-            <a:pPr indent="0" marL="0">
+            <a:pPr marL="0" indent="0">
               <a:lnSpc>
                 <a:spcPct val="130000"/>
               </a:lnSpc>
@@ -2145,7 +1894,7 @@
           <a:bodyPr wrap="square" lIns="0" tIns="0" rIns="0" bIns="0" rtlCol="0" anchor="ctr"/>
           <a:lstStyle/>
           <a:p>
-            <a:pPr indent="0" marL="0">
+            <a:pPr marL="0" indent="0">
               <a:buNone/>
             </a:pPr>
             <a:r>
@@ -2179,6 +1928,7 @@
         <a:solidFill>
           <a:srgbClr val="1B2A4A"/>
         </a:solidFill>
+        <a:effectLst/>
       </p:bgPr>
     </p:bg>
     <p:spTree>
@@ -2236,7 +1986,7 @@
           <a:bodyPr wrap="square" lIns="0" tIns="0" rIns="0" bIns="0" rtlCol="0" anchor="ctr"/>
           <a:lstStyle/>
           <a:p>
-            <a:pPr indent="0" marL="0">
+            <a:pPr marL="0" indent="0">
               <a:buNone/>
             </a:pPr>
             <a:r>
@@ -2295,7 +2045,7 @@
           <a:bodyPr wrap="square" lIns="0" tIns="0" rIns="0" bIns="0" rtlCol="0" anchor="ctr"/>
           <a:lstStyle/>
           <a:p>
-            <a:pPr algn="ctr" indent="0" marL="0">
+            <a:pPr marL="0" indent="0" algn="ctr">
               <a:buNone/>
             </a:pPr>
             <a:r>
@@ -2334,7 +2084,7 @@
           <a:bodyPr wrap="square" lIns="0" tIns="0" rIns="0" bIns="0" rtlCol="0" anchor="ctr"/>
           <a:lstStyle/>
           <a:p>
-            <a:pPr algn="ctr" indent="0" marL="0">
+            <a:pPr marL="0" indent="0" algn="ctr">
               <a:buNone/>
             </a:pPr>
             <a:r>
@@ -2393,7 +2143,7 @@
           <a:bodyPr wrap="square" lIns="0" tIns="0" rIns="0" bIns="0" rtlCol="0" anchor="ctr"/>
           <a:lstStyle/>
           <a:p>
-            <a:pPr algn="ctr" indent="0" marL="0">
+            <a:pPr marL="0" indent="0" algn="ctr">
               <a:buNone/>
             </a:pPr>
             <a:r>
@@ -2432,7 +2182,7 @@
           <a:bodyPr wrap="square" lIns="0" tIns="0" rIns="0" bIns="0" rtlCol="0" anchor="ctr"/>
           <a:lstStyle/>
           <a:p>
-            <a:pPr algn="ctr" indent="0" marL="0">
+            <a:pPr marL="0" indent="0" algn="ctr">
               <a:buNone/>
             </a:pPr>
             <a:r>
@@ -2491,7 +2241,7 @@
           <a:bodyPr wrap="square" lIns="0" tIns="0" rIns="0" bIns="0" rtlCol="0" anchor="ctr"/>
           <a:lstStyle/>
           <a:p>
-            <a:pPr algn="ctr" indent="0" marL="0">
+            <a:pPr marL="0" indent="0" algn="ctr">
               <a:buNone/>
             </a:pPr>
             <a:r>
@@ -2530,7 +2280,7 @@
           <a:bodyPr wrap="square" lIns="0" tIns="0" rIns="0" bIns="0" rtlCol="0" anchor="ctr"/>
           <a:lstStyle/>
           <a:p>
-            <a:pPr algn="ctr" indent="0" marL="0">
+            <a:pPr marL="0" indent="0" algn="ctr">
               <a:buNone/>
             </a:pPr>
             <a:r>
@@ -2589,7 +2339,7 @@
           <a:bodyPr wrap="square" lIns="0" tIns="0" rIns="0" bIns="0" rtlCol="0" anchor="ctr"/>
           <a:lstStyle/>
           <a:p>
-            <a:pPr algn="ctr" indent="0" marL="0">
+            <a:pPr marL="0" indent="0" algn="ctr">
               <a:buNone/>
             </a:pPr>
             <a:r>
@@ -2628,7 +2378,7 @@
           <a:bodyPr wrap="square" lIns="0" tIns="0" rIns="0" bIns="0" rtlCol="0" anchor="ctr"/>
           <a:lstStyle/>
           <a:p>
-            <a:pPr algn="ctr" indent="0" marL="0">
+            <a:pPr marL="0" indent="0" algn="ctr">
               <a:buNone/>
             </a:pPr>
             <a:r>
@@ -2687,7 +2437,7 @@
           <a:bodyPr wrap="square" lIns="0" tIns="0" rIns="0" bIns="0" rtlCol="0" anchor="ctr"/>
           <a:lstStyle/>
           <a:p>
-            <a:pPr algn="ctr" indent="0" marL="0">
+            <a:pPr marL="0" indent="0" algn="ctr">
               <a:buNone/>
             </a:pPr>
             <a:r>
@@ -2726,7 +2476,7 @@
           <a:bodyPr wrap="square" lIns="0" tIns="0" rIns="0" bIns="0" rtlCol="0" anchor="ctr"/>
           <a:lstStyle/>
           <a:p>
-            <a:pPr algn="ctr" indent="0" marL="0">
+            <a:pPr marL="0" indent="0" algn="ctr">
               <a:buNone/>
             </a:pPr>
             <a:r>
@@ -2763,7 +2513,7 @@
           </a:solidFill>
           <a:ln/>
           <a:effectLst>
-            <a:outerShdw sx="100000" sy="100000" kx="0" ky="0" algn="bl" rotWithShape="0" blurRad="76200" dist="25400" dir="8100000">
+            <a:outerShdw blurRad="76200" dist="25400" dir="8100000" algn="bl" rotWithShape="0">
               <a:srgbClr val="000000">
                 <a:alpha val="10000"/>
               </a:srgbClr>
@@ -2812,7 +2562,7 @@
           <a:bodyPr wrap="square" lIns="0" tIns="0" rIns="0" bIns="0" rtlCol="0" anchor="ctr"/>
           <a:lstStyle/>
           <a:p>
-            <a:pPr indent="0" marL="0">
+            <a:pPr marL="0" indent="0">
               <a:buNone/>
             </a:pPr>
             <a:r>
@@ -2851,7 +2601,7 @@
           <a:bodyPr wrap="square" lIns="0" tIns="0" rIns="0" bIns="0" rtlCol="0" anchor="ctr"/>
           <a:lstStyle/>
           <a:p>
-            <a:pPr indent="0" marL="0">
+            <a:pPr marL="0" indent="0">
               <a:spcAft>
                 <a:spcPts val="600"/>
               </a:spcAft>
@@ -2871,7 +2621,7 @@
             <a:endParaRPr lang="en-US" sz="1000" dirty="0"/>
           </a:p>
           <a:p>
-            <a:pPr indent="0" marL="0">
+            <a:pPr marL="0" indent="0">
               <a:spcAft>
                 <a:spcPts val="600"/>
               </a:spcAft>
@@ -2891,7 +2641,7 @@
             <a:endParaRPr lang="en-US" sz="1000" dirty="0"/>
           </a:p>
           <a:p>
-            <a:pPr indent="0" marL="0">
+            <a:pPr marL="0" indent="0">
               <a:spcAft>
                 <a:spcPts val="600"/>
               </a:spcAft>
@@ -2911,7 +2661,7 @@
             <a:endParaRPr lang="en-US" sz="1000" dirty="0"/>
           </a:p>
           <a:p>
-            <a:pPr indent="0" marL="0">
+            <a:pPr marL="0" indent="0">
               <a:spcAft>
                 <a:spcPts val="600"/>
               </a:spcAft>
@@ -2931,7 +2681,7 @@
             <a:endParaRPr lang="en-US" sz="1000" dirty="0"/>
           </a:p>
           <a:p>
-            <a:pPr indent="0" marL="0">
+            <a:pPr marL="0" indent="0">
               <a:spcAft>
                 <a:spcPts val="600"/>
               </a:spcAft>
@@ -2993,7 +2743,7 @@
           <a:bodyPr wrap="square" lIns="0" tIns="0" rIns="0" bIns="0" rtlCol="0" anchor="ctr"/>
           <a:lstStyle/>
           <a:p>
-            <a:pPr indent="0" marL="0">
+            <a:pPr marL="0" indent="0">
               <a:buNone/>
             </a:pPr>
             <a:r>
@@ -3027,6 +2777,7 @@
         <a:solidFill>
           <a:srgbClr val="F1F5F9"/>
         </a:solidFill>
+        <a:effectLst/>
       </p:bgPr>
     </p:bg>
     <p:spTree>
@@ -3084,7 +2835,7 @@
           <a:bodyPr wrap="square" lIns="0" tIns="0" rIns="0" bIns="0" rtlCol="0" anchor="ctr"/>
           <a:lstStyle/>
           <a:p>
-            <a:pPr indent="0" marL="0">
+            <a:pPr marL="0" indent="0">
               <a:buNone/>
             </a:pPr>
             <a:r>
@@ -3123,7 +2874,7 @@
           <a:bodyPr wrap="square" lIns="0" tIns="0" rIns="0" bIns="0" rtlCol="0" anchor="ctr"/>
           <a:lstStyle/>
           <a:p>
-            <a:pPr indent="0" marL="0">
+            <a:pPr marL="0" indent="0">
               <a:buNone/>
             </a:pPr>
             <a:r>
@@ -3162,7 +2913,7 @@
           <a:bodyPr wrap="square" lIns="0" tIns="0" rIns="0" bIns="0" rtlCol="0" anchor="ctr"/>
           <a:lstStyle/>
           <a:p>
-            <a:pPr indent="0" marL="0">
+            <a:pPr marL="0" indent="0">
               <a:buNone/>
             </a:pPr>
             <a:r>
@@ -3199,7 +2950,7 @@
           </a:solidFill>
           <a:ln/>
           <a:effectLst>
-            <a:outerShdw sx="100000" sy="100000" kx="0" ky="0" algn="bl" rotWithShape="0" blurRad="50800" dist="12700" dir="8100000">
+            <a:outerShdw blurRad="50800" dist="12700" dir="8100000" algn="bl" rotWithShape="0">
               <a:srgbClr val="000000">
                 <a:alpha val="8000"/>
               </a:srgbClr>
@@ -3248,7 +2999,7 @@
           <a:bodyPr wrap="square" lIns="0" tIns="0" rIns="0" bIns="0" rtlCol="0" anchor="ctr"/>
           <a:lstStyle/>
           <a:p>
-            <a:pPr indent="0" marL="0">
+            <a:pPr marL="0" indent="0">
               <a:buNone/>
             </a:pPr>
             <a:r>
@@ -3287,7 +3038,7 @@
           <a:bodyPr wrap="square" lIns="0" tIns="0" rIns="0" bIns="0" rtlCol="0" anchor="ctr"/>
           <a:lstStyle/>
           <a:p>
-            <a:pPr indent="0" marL="0">
+            <a:pPr marL="0" indent="0">
               <a:spcAft>
                 <a:spcPts val="600"/>
               </a:spcAft>
@@ -3307,7 +3058,7 @@
             <a:endParaRPr lang="en-US" sz="1100" dirty="0"/>
           </a:p>
           <a:p>
-            <a:pPr indent="0" marL="0">
+            <a:pPr marL="0" indent="0">
               <a:spcAft>
                 <a:spcPts val="600"/>
               </a:spcAft>
@@ -3327,7 +3078,7 @@
             <a:endParaRPr lang="en-US" sz="1100" dirty="0"/>
           </a:p>
           <a:p>
-            <a:pPr indent="0" marL="0">
+            <a:pPr marL="0" indent="0">
               <a:spcAft>
                 <a:spcPts val="600"/>
               </a:spcAft>
@@ -3347,7 +3098,7 @@
             <a:endParaRPr lang="en-US" sz="1100" dirty="0"/>
           </a:p>
           <a:p>
-            <a:pPr indent="0" marL="0">
+            <a:pPr marL="0" indent="0">
               <a:spcAft>
                 <a:spcPts val="600"/>
               </a:spcAft>
@@ -3367,7 +3118,7 @@
             <a:endParaRPr lang="en-US" sz="1100" dirty="0"/>
           </a:p>
           <a:p>
-            <a:pPr indent="0" marL="0">
+            <a:pPr marL="0" indent="0">
               <a:spcAft>
                 <a:spcPts val="600"/>
               </a:spcAft>
@@ -3387,7 +3138,7 @@
             <a:endParaRPr lang="en-US" sz="1100" dirty="0"/>
           </a:p>
           <a:p>
-            <a:pPr indent="0" marL="0">
+            <a:pPr marL="0" indent="0">
               <a:spcAft>
                 <a:spcPts val="600"/>
               </a:spcAft>
@@ -3427,7 +3178,7 @@
           </a:solidFill>
           <a:ln/>
           <a:effectLst>
-            <a:outerShdw sx="100000" sy="100000" kx="0" ky="0" algn="bl" rotWithShape="0" blurRad="50800" dist="12700" dir="8100000">
+            <a:outerShdw blurRad="50800" dist="12700" dir="8100000" algn="bl" rotWithShape="0">
               <a:srgbClr val="000000">
                 <a:alpha val="8000"/>
               </a:srgbClr>
@@ -3476,7 +3227,7 @@
           <a:bodyPr wrap="square" lIns="0" tIns="0" rIns="0" bIns="0" rtlCol="0" anchor="ctr"/>
           <a:lstStyle/>
           <a:p>
-            <a:pPr indent="0" marL="0">
+            <a:pPr marL="0" indent="0">
               <a:buNone/>
             </a:pPr>
             <a:r>
@@ -3515,7 +3266,7 @@
           <a:bodyPr wrap="square" lIns="0" tIns="0" rIns="0" bIns="0" rtlCol="0" anchor="ctr"/>
           <a:lstStyle/>
           <a:p>
-            <a:pPr indent="0" marL="0">
+            <a:pPr marL="0" indent="0">
               <a:spcAft>
                 <a:spcPts val="600"/>
               </a:spcAft>
@@ -3535,7 +3286,7 @@
             <a:endParaRPr lang="en-US" sz="1100" dirty="0"/>
           </a:p>
           <a:p>
-            <a:pPr indent="0" marL="0">
+            <a:pPr marL="0" indent="0">
               <a:spcAft>
                 <a:spcPts val="600"/>
               </a:spcAft>
@@ -3555,7 +3306,7 @@
             <a:endParaRPr lang="en-US" sz="1100" dirty="0"/>
           </a:p>
           <a:p>
-            <a:pPr indent="0" marL="0">
+            <a:pPr marL="0" indent="0">
               <a:spcAft>
                 <a:spcPts val="600"/>
               </a:spcAft>
@@ -3575,7 +3326,7 @@
             <a:endParaRPr lang="en-US" sz="1100" dirty="0"/>
           </a:p>
           <a:p>
-            <a:pPr indent="0" marL="0">
+            <a:pPr marL="0" indent="0">
               <a:spcAft>
                 <a:spcPts val="600"/>
               </a:spcAft>
@@ -3595,7 +3346,7 @@
             <a:endParaRPr lang="en-US" sz="1100" dirty="0"/>
           </a:p>
           <a:p>
-            <a:pPr indent="0" marL="0">
+            <a:pPr marL="0" indent="0">
               <a:spcAft>
                 <a:spcPts val="600"/>
               </a:spcAft>
@@ -3637,7 +3388,7 @@
           <a:bodyPr wrap="square" lIns="0" tIns="0" rIns="0" bIns="0" rtlCol="0" anchor="ctr"/>
           <a:lstStyle/>
           <a:p>
-            <a:pPr indent="0" marL="0">
+            <a:pPr marL="0" indent="0">
               <a:buNone/>
             </a:pPr>
             <a:r>
@@ -3668,6 +3419,7 @@
         <a:solidFill>
           <a:srgbClr val="F1F5F9"/>
         </a:solidFill>
+        <a:effectLst/>
       </p:bgPr>
     </p:bg>
     <p:spTree>
@@ -3725,7 +3477,7 @@
           <a:bodyPr wrap="square" lIns="0" tIns="0" rIns="0" bIns="0" rtlCol="0" anchor="ctr"/>
           <a:lstStyle/>
           <a:p>
-            <a:pPr indent="0" marL="0">
+            <a:pPr marL="0" indent="0">
               <a:buNone/>
             </a:pPr>
             <a:r>
@@ -3764,7 +3516,7 @@
           <a:bodyPr wrap="square" lIns="0" tIns="0" rIns="0" bIns="0" rtlCol="0" anchor="ctr"/>
           <a:lstStyle/>
           <a:p>
-            <a:pPr indent="0" marL="0">
+            <a:pPr marL="0" indent="0">
               <a:buNone/>
             </a:pPr>
             <a:r>
@@ -3803,7 +3555,7 @@
           <a:bodyPr wrap="square" lIns="0" tIns="0" rIns="0" bIns="0" rtlCol="0" anchor="ctr"/>
           <a:lstStyle/>
           <a:p>
-            <a:pPr indent="0" marL="0">
+            <a:pPr marL="0" indent="0">
               <a:buNone/>
             </a:pPr>
             <a:r>
@@ -3832,7 +3584,7 @@
             <a:off x="502920" y="1463040"/>
             <a:ext cx="502920" cy="502920"/>
           </a:xfrm>
-          <a:prstGeom prst="oval">
+          <a:prstGeom prst="line">
             <a:avLst/>
           </a:prstGeom>
           <a:solidFill>
@@ -3843,14 +3595,14 @@
       </p:sp>
       <p:pic>
         <p:nvPicPr>
-          <p:cNvPr id="7" name="Image 0" descr="preencoded.png">    </p:cNvPr>
+          <p:cNvPr id="7" name="Image 0" descr="preencoded.png"/>
           <p:cNvPicPr>
             <a:picLocks noChangeAspect="1"/>
           </p:cNvPicPr>
           <p:nvPr/>
         </p:nvPicPr>
         <p:blipFill>
-          <a:blip r:embed="rId1"/>
+          <a:blip r:embed="rId3"/>
           <a:stretch>
             <a:fillRect/>
           </a:stretch>
@@ -3886,7 +3638,7 @@
           <a:bodyPr wrap="square" lIns="0" tIns="0" rIns="0" bIns="0" rtlCol="0" anchor="ctr"/>
           <a:lstStyle/>
           <a:p>
-            <a:pPr indent="0" marL="0">
+            <a:pPr marL="0" indent="0">
               <a:buNone/>
             </a:pPr>
             <a:r>
@@ -3925,7 +3677,7 @@
           <a:bodyPr wrap="square" lIns="0" tIns="0" rIns="0" bIns="0" rtlCol="0" anchor="ctr"/>
           <a:lstStyle/>
           <a:p>
-            <a:pPr algn="ctr" indent="0" marL="0">
+            <a:pPr marL="0" indent="0" algn="ctr">
               <a:buNone/>
             </a:pPr>
             <a:r>
@@ -3959,7 +3711,7 @@
           </a:solidFill>
           <a:ln/>
           <a:effectLst>
-            <a:outerShdw sx="100000" sy="100000" kx="0" ky="0" algn="bl" rotWithShape="0" blurRad="76200" dist="25400" dir="8100000">
+            <a:outerShdw blurRad="76200" dist="25400" dir="8100000" algn="bl" rotWithShape="0">
               <a:srgbClr val="000000">
                 <a:alpha val="10000"/>
               </a:srgbClr>
@@ -3988,7 +3740,7 @@
           <a:bodyPr wrap="square" lIns="0" tIns="0" rIns="0" bIns="0" rtlCol="0" anchor="ctr"/>
           <a:lstStyle/>
           <a:p>
-            <a:pPr algn="ctr" indent="0" marL="0">
+            <a:pPr marL="0" indent="0" algn="ctr">
               <a:buNone/>
             </a:pPr>
             <a:r>
@@ -4002,7 +3754,7 @@
             <a:endParaRPr lang="en-US" sz="1200" dirty="0"/>
           </a:p>
           <a:p>
-            <a:pPr algn="ctr" indent="0" marL="0">
+            <a:pPr marL="0" indent="0" algn="ctr">
               <a:buNone/>
             </a:pPr>
             <a:r>
@@ -4038,7 +3790,7 @@
           <a:bodyPr wrap="square" lIns="0" tIns="0" rIns="0" bIns="0" rtlCol="0" anchor="ctr"/>
           <a:lstStyle/>
           <a:p>
-            <a:pPr algn="ctr" indent="0" marL="0">
+            <a:pPr marL="0" indent="0" algn="ctr">
               <a:buNone/>
             </a:pPr>
             <a:r>
@@ -4072,7 +3824,7 @@
           </a:solidFill>
           <a:ln/>
           <a:effectLst>
-            <a:outerShdw sx="100000" sy="100000" kx="0" ky="0" algn="bl" rotWithShape="0" blurRad="76200" dist="25400" dir="8100000">
+            <a:outerShdw blurRad="76200" dist="25400" dir="8100000" algn="bl" rotWithShape="0">
               <a:srgbClr val="000000">
                 <a:alpha val="10000"/>
               </a:srgbClr>
@@ -4101,7 +3853,7 @@
           <a:bodyPr wrap="square" lIns="0" tIns="0" rIns="0" bIns="0" rtlCol="0" anchor="ctr"/>
           <a:lstStyle/>
           <a:p>
-            <a:pPr algn="ctr" indent="0" marL="0">
+            <a:pPr marL="0" indent="0" algn="ctr">
               <a:buNone/>
             </a:pPr>
             <a:r>
@@ -4115,7 +3867,7 @@
             <a:endParaRPr lang="en-US" sz="1200" dirty="0"/>
           </a:p>
           <a:p>
-            <a:pPr algn="ctr" indent="0" marL="0">
+            <a:pPr marL="0" indent="0" algn="ctr">
               <a:buNone/>
             </a:pPr>
             <a:r>
@@ -4151,7 +3903,7 @@
           <a:bodyPr wrap="square" lIns="0" tIns="0" rIns="0" bIns="0" rtlCol="0" anchor="ctr"/>
           <a:lstStyle/>
           <a:p>
-            <a:pPr algn="ctr" indent="0" marL="0">
+            <a:pPr marL="0" indent="0" algn="ctr">
               <a:buNone/>
             </a:pPr>
             <a:r>
@@ -4185,7 +3937,7 @@
           </a:solidFill>
           <a:ln/>
           <a:effectLst>
-            <a:outerShdw sx="100000" sy="100000" kx="0" ky="0" algn="bl" rotWithShape="0" blurRad="76200" dist="25400" dir="8100000">
+            <a:outerShdw blurRad="76200" dist="25400" dir="8100000" algn="bl" rotWithShape="0">
               <a:srgbClr val="000000">
                 <a:alpha val="10000"/>
               </a:srgbClr>
@@ -4214,7 +3966,7 @@
           <a:bodyPr wrap="square" lIns="0" tIns="0" rIns="0" bIns="0" rtlCol="0" anchor="ctr"/>
           <a:lstStyle/>
           <a:p>
-            <a:pPr algn="ctr" indent="0" marL="0">
+            <a:pPr marL="0" indent="0" algn="ctr">
               <a:buNone/>
             </a:pPr>
             <a:r>
@@ -4228,7 +3980,7 @@
             <a:endParaRPr lang="en-US" sz="1100" dirty="0"/>
           </a:p>
           <a:p>
-            <a:pPr algn="ctr" indent="0" marL="0">
+            <a:pPr marL="0" indent="0" algn="ctr">
               <a:buNone/>
             </a:pPr>
             <a:r>
@@ -4262,7 +4014,7 @@
           </a:solidFill>
           <a:ln/>
           <a:effectLst>
-            <a:outerShdw sx="100000" sy="100000" kx="0" ky="0" algn="bl" rotWithShape="0" blurRad="50800" dist="12700" dir="8100000">
+            <a:outerShdw blurRad="50800" dist="12700" dir="8100000" algn="bl" rotWithShape="0">
               <a:srgbClr val="000000">
                 <a:alpha val="8000"/>
               </a:srgbClr>
@@ -4291,7 +4043,7 @@
           <a:bodyPr wrap="square" lIns="0" tIns="0" rIns="0" bIns="0" rtlCol="0" anchor="ctr"/>
           <a:lstStyle/>
           <a:p>
-            <a:pPr indent="0" marL="0">
+            <a:pPr marL="0" indent="0">
               <a:buNone/>
             </a:pPr>
             <a:r>
@@ -4330,7 +4082,7 @@
           <a:bodyPr wrap="square" lIns="0" tIns="0" rIns="0" bIns="0" rtlCol="0" anchor="ctr"/>
           <a:lstStyle/>
           <a:p>
-            <a:pPr indent="0" marL="0">
+            <a:pPr marL="0" indent="0">
               <a:buNone/>
             </a:pPr>
             <a:r>
@@ -4344,9 +4096,6 @@
               </a:rPr>
               <a:t>query_drilling_data</a:t>
             </a:r>
-            <a:pPr indent="0" marL="0">
-              <a:buNone/>
-            </a:pPr>
             <a:r>
               <a:rPr lang="en-US" sz="850" dirty="0">
                 <a:solidFill>
@@ -4383,7 +4132,7 @@
           <a:bodyPr wrap="square" lIns="0" tIns="0" rIns="0" bIns="0" rtlCol="0" anchor="ctr"/>
           <a:lstStyle/>
           <a:p>
-            <a:pPr indent="0" marL="0">
+            <a:pPr marL="0" indent="0">
               <a:buNone/>
             </a:pPr>
             <a:r>
@@ -4397,9 +4146,6 @@
               </a:rPr>
               <a:t>search_daily_reports</a:t>
             </a:r>
-            <a:pPr indent="0" marL="0">
-              <a:buNone/>
-            </a:pPr>
             <a:r>
               <a:rPr lang="en-US" sz="850" dirty="0">
                 <a:solidFill>
@@ -4436,7 +4182,7 @@
           <a:bodyPr wrap="square" lIns="0" tIns="0" rIns="0" bIns="0" rtlCol="0" anchor="ctr"/>
           <a:lstStyle/>
           <a:p>
-            <a:pPr indent="0" marL="0">
+            <a:pPr marL="0" indent="0">
               <a:buNone/>
             </a:pPr>
             <a:r>
@@ -4450,9 +4196,6 @@
               </a:rPr>
               <a:t>get_well_overview</a:t>
             </a:r>
-            <a:pPr indent="0" marL="0">
-              <a:buNone/>
-            </a:pPr>
             <a:r>
               <a:rPr lang="en-US" sz="850" dirty="0">
                 <a:solidFill>
@@ -4489,7 +4232,7 @@
           <a:bodyPr wrap="square" lIns="0" tIns="0" rIns="0" bIns="0" rtlCol="0" anchor="ctr"/>
           <a:lstStyle/>
           <a:p>
-            <a:pPr indent="0" marL="0">
+            <a:pPr marL="0" indent="0">
               <a:buNone/>
             </a:pPr>
             <a:r>
@@ -4503,9 +4246,6 @@
               </a:rPr>
               <a:t>get_drilling_phases</a:t>
             </a:r>
-            <a:pPr indent="0" marL="0">
-              <a:buNone/>
-            </a:pPr>
             <a:r>
               <a:rPr lang="en-US" sz="850" dirty="0">
                 <a:solidFill>
@@ -4542,7 +4282,7 @@
           <a:bodyPr wrap="square" lIns="0" tIns="0" rIns="0" bIns="0" rtlCol="0" anchor="ctr"/>
           <a:lstStyle/>
           <a:p>
-            <a:pPr indent="0" marL="0">
+            <a:pPr marL="0" indent="0">
               <a:buNone/>
             </a:pPr>
             <a:r>
@@ -4556,9 +4296,6 @@
               </a:rPr>
               <a:t>compute_efficiency</a:t>
             </a:r>
-            <a:pPr indent="0" marL="0">
-              <a:buNone/>
-            </a:pPr>
             <a:r>
               <a:rPr lang="en-US" sz="850" dirty="0">
                 <a:solidFill>
@@ -4595,7 +4332,7 @@
           <a:bodyPr wrap="square" lIns="0" tIns="0" rIns="0" bIns="0" rtlCol="0" anchor="ctr"/>
           <a:lstStyle/>
           <a:p>
-            <a:pPr indent="0" marL="0">
+            <a:pPr marL="0" indent="0">
               <a:buNone/>
             </a:pPr>
             <a:r>
@@ -4609,9 +4346,6 @@
               </a:rPr>
               <a:t>compare_wells</a:t>
             </a:r>
-            <a:pPr indent="0" marL="0">
-              <a:buNone/>
-            </a:pPr>
             <a:r>
               <a:rPr lang="en-US" sz="850" dirty="0">
                 <a:solidFill>
@@ -4648,7 +4382,7 @@
           <a:bodyPr wrap="square" lIns="0" tIns="0" rIns="0" bIns="0" rtlCol="0" anchor="ctr"/>
           <a:lstStyle/>
           <a:p>
-            <a:pPr indent="0" marL="0">
+            <a:pPr marL="0" indent="0">
               <a:buNone/>
             </a:pPr>
             <a:r>
@@ -4662,9 +4396,6 @@
               </a:rPr>
               <a:t>get_bha_configurations</a:t>
             </a:r>
-            <a:pPr indent="0" marL="0">
-              <a:buNone/>
-            </a:pPr>
             <a:r>
               <a:rPr lang="en-US" sz="850" dirty="0">
                 <a:solidFill>
@@ -4701,7 +4432,7 @@
           <a:bodyPr wrap="square" lIns="0" tIns="0" rIns="0" bIns="0" rtlCol="0" anchor="ctr"/>
           <a:lstStyle/>
           <a:p>
-            <a:pPr indent="0" marL="0">
+            <a:pPr marL="0" indent="0">
               <a:buNone/>
             </a:pPr>
             <a:r>
@@ -4715,9 +4446,6 @@
               </a:rPr>
               <a:t>identify_issues</a:t>
             </a:r>
-            <a:pPr indent="0" marL="0">
-              <a:buNone/>
-            </a:pPr>
             <a:r>
               <a:rPr lang="en-US" sz="850" dirty="0">
                 <a:solidFill>
@@ -4754,7 +4482,7 @@
           <a:bodyPr wrap="square" lIns="0" tIns="0" rIns="0" bIns="0" rtlCol="0" anchor="ctr"/>
           <a:lstStyle/>
           <a:p>
-            <a:pPr indent="0" marL="0">
+            <a:pPr marL="0" indent="0">
               <a:buNone/>
             </a:pPr>
             <a:r>
@@ -4768,9 +4496,6 @@
               </a:rPr>
               <a:t>get_formation_context</a:t>
             </a:r>
-            <a:pPr indent="0" marL="0">
-              <a:buNone/>
-            </a:pPr>
             <a:r>
               <a:rPr lang="en-US" sz="850" dirty="0">
                 <a:solidFill>
@@ -4807,7 +4532,7 @@
           <a:bodyPr wrap="square" lIns="0" tIns="0" rIns="0" bIns="0" rtlCol="0" anchor="ctr"/>
           <a:lstStyle/>
           <a:p>
-            <a:pPr indent="0" marL="0">
+            <a:pPr marL="0" indent="0">
               <a:buNone/>
             </a:pPr>
             <a:r>
@@ -4821,9 +4546,6 @@
               </a:rPr>
               <a:t>get_field_benchmarks</a:t>
             </a:r>
-            <a:pPr indent="0" marL="0">
-              <a:buNone/>
-            </a:pPr>
             <a:r>
               <a:rPr lang="en-US" sz="850" dirty="0">
                 <a:solidFill>
@@ -4860,7 +4582,7 @@
           <a:bodyPr wrap="square" lIns="0" tIns="0" rIns="0" bIns="0" rtlCol="0" anchor="ctr"/>
           <a:lstStyle/>
           <a:p>
-            <a:pPr indent="0" marL="0">
+            <a:pPr marL="0" indent="0">
               <a:buNone/>
             </a:pPr>
             <a:r>
@@ -4874,9 +4596,6 @@
               </a:rPr>
               <a:t>get_ddr_narrative</a:t>
             </a:r>
-            <a:pPr indent="0" marL="0">
-              <a:buNone/>
-            </a:pPr>
             <a:r>
               <a:rPr lang="en-US" sz="850" dirty="0">
                 <a:solidFill>
@@ -4913,7 +4632,7 @@
           <a:bodyPr wrap="square" lIns="0" tIns="0" rIns="0" bIns="0" rtlCol="0" anchor="ctr"/>
           <a:lstStyle/>
           <a:p>
-            <a:pPr indent="0" marL="0">
+            <a:pPr marL="0" indent="0">
               <a:buNone/>
             </a:pPr>
             <a:r>
@@ -4927,9 +4646,6 @@
               </a:rPr>
               <a:t>generate_depth_time_plot</a:t>
             </a:r>
-            <a:pPr indent="0" marL="0">
-              <a:buNone/>
-            </a:pPr>
             <a:r>
               <a:rPr lang="en-US" sz="850" dirty="0">
                 <a:solidFill>
@@ -4961,6 +4677,7 @@
         <a:solidFill>
           <a:srgbClr val="F1F5F9"/>
         </a:solidFill>
+        <a:effectLst/>
       </p:bgPr>
     </p:bg>
     <p:spTree>
@@ -5018,7 +4735,7 @@
           <a:bodyPr wrap="square" lIns="0" tIns="0" rIns="0" bIns="0" rtlCol="0" anchor="ctr"/>
           <a:lstStyle/>
           <a:p>
-            <a:pPr indent="0" marL="0">
+            <a:pPr marL="0" indent="0">
               <a:buNone/>
             </a:pPr>
             <a:r>
@@ -5057,7 +4774,7 @@
           <a:bodyPr wrap="square" lIns="0" tIns="0" rIns="0" bIns="0" rtlCol="0" anchor="ctr"/>
           <a:lstStyle/>
           <a:p>
-            <a:pPr indent="0" marL="0">
+            <a:pPr marL="0" indent="0">
               <a:buNone/>
             </a:pPr>
             <a:r>
@@ -5096,7 +4813,7 @@
           <a:bodyPr wrap="square" lIns="0" tIns="0" rIns="0" bIns="0" rtlCol="0" anchor="ctr"/>
           <a:lstStyle/>
           <a:p>
-            <a:pPr indent="0" marL="0">
+            <a:pPr marL="0" indent="0">
               <a:buNone/>
             </a:pPr>
             <a:r>
@@ -5133,7 +4850,7 @@
           </a:solidFill>
           <a:ln/>
           <a:effectLst>
-            <a:outerShdw sx="100000" sy="100000" kx="0" ky="0" algn="bl" rotWithShape="0" blurRad="50800" dist="12700" dir="8100000">
+            <a:outerShdw blurRad="50800" dist="12700" dir="8100000" algn="bl" rotWithShape="0">
               <a:srgbClr val="000000">
                 <a:alpha val="8000"/>
               </a:srgbClr>
@@ -5162,7 +4879,7 @@
           <a:bodyPr wrap="square" lIns="0" tIns="0" rIns="0" bIns="0" rtlCol="0" anchor="ctr"/>
           <a:lstStyle/>
           <a:p>
-            <a:pPr algn="ctr" indent="0" marL="0">
+            <a:pPr marL="0" indent="0" algn="ctr">
               <a:buNone/>
             </a:pPr>
             <a:r>
@@ -5201,7 +4918,7 @@
           <a:bodyPr wrap="square" lIns="0" tIns="0" rIns="0" bIns="0" rtlCol="0" anchor="ctr"/>
           <a:lstStyle/>
           <a:p>
-            <a:pPr algn="ctr" indent="0" marL="0">
+            <a:pPr marL="0" indent="0" algn="ctr">
               <a:buNone/>
             </a:pPr>
             <a:r>
@@ -5238,7 +4955,7 @@
           </a:solidFill>
           <a:ln/>
           <a:effectLst>
-            <a:outerShdw sx="100000" sy="100000" kx="0" ky="0" algn="bl" rotWithShape="0" blurRad="50800" dist="12700" dir="8100000">
+            <a:outerShdw blurRad="50800" dist="12700" dir="8100000" algn="bl" rotWithShape="0">
               <a:srgbClr val="000000">
                 <a:alpha val="8000"/>
               </a:srgbClr>
@@ -5267,7 +4984,7 @@
           <a:bodyPr wrap="square" lIns="0" tIns="0" rIns="0" bIns="0" rtlCol="0" anchor="ctr"/>
           <a:lstStyle/>
           <a:p>
-            <a:pPr algn="ctr" indent="0" marL="0">
+            <a:pPr marL="0" indent="0" algn="ctr">
               <a:buNone/>
             </a:pPr>
             <a:r>
@@ -5306,7 +5023,7 @@
           <a:bodyPr wrap="square" lIns="0" tIns="0" rIns="0" bIns="0" rtlCol="0" anchor="ctr"/>
           <a:lstStyle/>
           <a:p>
-            <a:pPr algn="ctr" indent="0" marL="0">
+            <a:pPr marL="0" indent="0" algn="ctr">
               <a:buNone/>
             </a:pPr>
             <a:r>
@@ -5343,7 +5060,7 @@
           </a:solidFill>
           <a:ln/>
           <a:effectLst>
-            <a:outerShdw sx="100000" sy="100000" kx="0" ky="0" algn="bl" rotWithShape="0" blurRad="50800" dist="12700" dir="8100000">
+            <a:outerShdw blurRad="50800" dist="12700" dir="8100000" algn="bl" rotWithShape="0">
               <a:srgbClr val="000000">
                 <a:alpha val="8000"/>
               </a:srgbClr>
@@ -5372,7 +5089,7 @@
           <a:bodyPr wrap="square" lIns="0" tIns="0" rIns="0" bIns="0" rtlCol="0" anchor="ctr"/>
           <a:lstStyle/>
           <a:p>
-            <a:pPr algn="ctr" indent="0" marL="0">
+            <a:pPr marL="0" indent="0" algn="ctr">
               <a:buNone/>
             </a:pPr>
             <a:r>
@@ -5411,7 +5128,7 @@
           <a:bodyPr wrap="square" lIns="0" tIns="0" rIns="0" bIns="0" rtlCol="0" anchor="ctr"/>
           <a:lstStyle/>
           <a:p>
-            <a:pPr algn="ctr" indent="0" marL="0">
+            <a:pPr marL="0" indent="0" algn="ctr">
               <a:buNone/>
             </a:pPr>
             <a:r>
@@ -5448,7 +5165,7 @@
           </a:solidFill>
           <a:ln/>
           <a:effectLst>
-            <a:outerShdw sx="100000" sy="100000" kx="0" ky="0" algn="bl" rotWithShape="0" blurRad="50800" dist="12700" dir="8100000">
+            <a:outerShdw blurRad="50800" dist="12700" dir="8100000" algn="bl" rotWithShape="0">
               <a:srgbClr val="000000">
                 <a:alpha val="8000"/>
               </a:srgbClr>
@@ -5477,7 +5194,7 @@
           <a:bodyPr wrap="square" lIns="0" tIns="0" rIns="0" bIns="0" rtlCol="0" anchor="ctr"/>
           <a:lstStyle/>
           <a:p>
-            <a:pPr algn="ctr" indent="0" marL="0">
+            <a:pPr marL="0" indent="0" algn="ctr">
               <a:buNone/>
             </a:pPr>
             <a:r>
@@ -5516,7 +5233,7 @@
           <a:bodyPr wrap="square" lIns="0" tIns="0" rIns="0" bIns="0" rtlCol="0" anchor="ctr"/>
           <a:lstStyle/>
           <a:p>
-            <a:pPr algn="ctr" indent="0" marL="0">
+            <a:pPr marL="0" indent="0" algn="ctr">
               <a:buNone/>
             </a:pPr>
             <a:r>
@@ -5553,7 +5270,7 @@
           </a:solidFill>
           <a:ln/>
           <a:effectLst>
-            <a:outerShdw sx="100000" sy="100000" kx="0" ky="0" algn="bl" rotWithShape="0" blurRad="50800" dist="12700" dir="8100000">
+            <a:outerShdw blurRad="50800" dist="12700" dir="8100000" algn="bl" rotWithShape="0">
               <a:srgbClr val="000000">
                 <a:alpha val="8000"/>
               </a:srgbClr>
@@ -5582,7 +5299,7 @@
           <a:bodyPr wrap="square" lIns="0" tIns="0" rIns="0" bIns="0" rtlCol="0" anchor="ctr"/>
           <a:lstStyle/>
           <a:p>
-            <a:pPr algn="ctr" indent="0" marL="0">
+            <a:pPr marL="0" indent="0" algn="ctr">
               <a:buNone/>
             </a:pPr>
             <a:r>
@@ -5621,7 +5338,7 @@
           <a:bodyPr wrap="square" lIns="0" tIns="0" rIns="0" bIns="0" rtlCol="0" anchor="ctr"/>
           <a:lstStyle/>
           <a:p>
-            <a:pPr algn="ctr" indent="0" marL="0">
+            <a:pPr marL="0" indent="0" algn="ctr">
               <a:buNone/>
             </a:pPr>
             <a:r>
@@ -5641,7 +5358,7 @@
       </p:sp>
       <p:graphicFrame>
         <p:nvGraphicFramePr>
-          <p:cNvPr id="21" name="Chart 0" descr=""/>
+          <p:cNvPr id="21" name="Chart 0"/>
           <p:cNvGraphicFramePr/>
           <p:nvPr/>
         </p:nvGraphicFramePr>
@@ -5649,9 +5366,9 @@
           <a:off x="457200" y="2560320"/>
           <a:ext cx="5029200" cy="2103120"/>
         </p:xfrm>
-        <a:graphic xmlns:a="http://schemas.openxmlformats.org/drawingml/2006/main">
+        <a:graphic>
           <a:graphicData uri="http://schemas.openxmlformats.org/drawingml/2006/chart">
-            <c:chart xmlns:c="http://schemas.openxmlformats.org/drawingml/2006/chart" r:id="rId1"/>
+            <c:chart xmlns:c="http://schemas.openxmlformats.org/drawingml/2006/chart" xmlns:r="http://schemas.openxmlformats.org/officeDocument/2006/relationships" r:id="rId3"/>
           </a:graphicData>
         </a:graphic>
       </p:graphicFrame>
@@ -5674,7 +5391,7 @@
           </a:solidFill>
           <a:ln/>
           <a:effectLst>
-            <a:outerShdw sx="100000" sy="100000" kx="0" ky="0" algn="bl" rotWithShape="0" blurRad="50800" dist="12700" dir="8100000">
+            <a:outerShdw blurRad="50800" dist="12700" dir="8100000" algn="bl" rotWithShape="0">
               <a:srgbClr val="000000">
                 <a:alpha val="8000"/>
               </a:srgbClr>
@@ -5723,7 +5440,7 @@
           <a:bodyPr wrap="square" lIns="0" tIns="0" rIns="0" bIns="0" rtlCol="0" anchor="ctr"/>
           <a:lstStyle/>
           <a:p>
-            <a:pPr indent="0" marL="0">
+            <a:pPr marL="0" indent="0">
               <a:buNone/>
             </a:pPr>
             <a:r>
@@ -5905,6 +5622,7 @@
         <a:solidFill>
           <a:srgbClr val="F1F5F9"/>
         </a:solidFill>
+        <a:effectLst/>
       </p:bgPr>
     </p:bg>
     <p:spTree>
@@ -5962,7 +5680,7 @@
           <a:bodyPr wrap="square" lIns="0" tIns="0" rIns="0" bIns="0" rtlCol="0" anchor="ctr"/>
           <a:lstStyle/>
           <a:p>
-            <a:pPr indent="0" marL="0">
+            <a:pPr marL="0" indent="0">
               <a:buNone/>
             </a:pPr>
             <a:r>
@@ -6001,7 +5719,7 @@
           <a:bodyPr wrap="square" lIns="0" tIns="0" rIns="0" bIns="0" rtlCol="0" anchor="ctr"/>
           <a:lstStyle/>
           <a:p>
-            <a:pPr indent="0" marL="0">
+            <a:pPr marL="0" indent="0">
               <a:buNone/>
             </a:pPr>
             <a:r>
@@ -6040,7 +5758,7 @@
           <a:bodyPr wrap="square" lIns="0" tIns="0" rIns="0" bIns="0" rtlCol="0" anchor="ctr"/>
           <a:lstStyle/>
           <a:p>
-            <a:pPr indent="0" marL="0">
+            <a:pPr marL="0" indent="0">
               <a:buNone/>
             </a:pPr>
             <a:r>
@@ -6077,7 +5795,7 @@
           </a:solidFill>
           <a:ln/>
           <a:effectLst>
-            <a:outerShdw sx="100000" sy="100000" kx="0" ky="0" algn="bl" rotWithShape="0" blurRad="50800" dist="12700" dir="8100000">
+            <a:outerShdw blurRad="50800" dist="12700" dir="8100000" algn="bl" rotWithShape="0">
               <a:srgbClr val="000000">
                 <a:alpha val="8000"/>
               </a:srgbClr>
@@ -6126,7 +5844,7 @@
           <a:bodyPr wrap="square" lIns="0" tIns="0" rIns="0" bIns="0" rtlCol="0" anchor="ctr"/>
           <a:lstStyle/>
           <a:p>
-            <a:pPr indent="0" marL="0">
+            <a:pPr marL="0" indent="0">
               <a:buNone/>
             </a:pPr>
             <a:r>
@@ -6155,7 +5873,7 @@
             <a:off x="685800" y="1828800"/>
             <a:ext cx="256032" cy="256032"/>
           </a:xfrm>
-          <a:prstGeom prst="oval">
+          <a:prstGeom prst="line">
             <a:avLst/>
           </a:prstGeom>
           <a:solidFill>
@@ -6185,7 +5903,7 @@
           <a:bodyPr wrap="square" lIns="0" tIns="0" rIns="0" bIns="0" rtlCol="0" anchor="ctr"/>
           <a:lstStyle/>
           <a:p>
-            <a:pPr algn="ctr" indent="0" marL="0">
+            <a:pPr marL="0" indent="0" algn="ctr">
               <a:buNone/>
             </a:pPr>
             <a:r>
@@ -6224,7 +5942,7 @@
           <a:bodyPr wrap="square" lIns="0" tIns="0" rIns="0" bIns="0" rtlCol="0" anchor="ctr"/>
           <a:lstStyle/>
           <a:p>
-            <a:pPr indent="0" marL="0">
+            <a:pPr marL="0" indent="0">
               <a:buNone/>
             </a:pPr>
             <a:r>
@@ -6235,9 +5953,6 @@
               </a:rPr>
               <a:t>Answer</a:t>
             </a:r>
-            <a:pPr indent="0" marL="0">
-              <a:buNone/>
-            </a:pPr>
             <a:r>
               <a:rPr lang="en-US" sz="1000" dirty="0">
                 <a:solidFill>
@@ -6261,7 +5976,7 @@
             <a:off x="685800" y="2258568"/>
             <a:ext cx="256032" cy="256032"/>
           </a:xfrm>
-          <a:prstGeom prst="oval">
+          <a:prstGeom prst="line">
             <a:avLst/>
           </a:prstGeom>
           <a:solidFill>
@@ -6291,7 +6006,7 @@
           <a:bodyPr wrap="square" lIns="0" tIns="0" rIns="0" bIns="0" rtlCol="0" anchor="ctr"/>
           <a:lstStyle/>
           <a:p>
-            <a:pPr algn="ctr" indent="0" marL="0">
+            <a:pPr marL="0" indent="0" algn="ctr">
               <a:buNone/>
             </a:pPr>
             <a:r>
@@ -6330,7 +6045,7 @@
           <a:bodyPr wrap="square" lIns="0" tIns="0" rIns="0" bIns="0" rtlCol="0" anchor="ctr"/>
           <a:lstStyle/>
           <a:p>
-            <a:pPr indent="0" marL="0">
+            <a:pPr marL="0" indent="0">
               <a:buNone/>
             </a:pPr>
             <a:r>
@@ -6341,9 +6056,6 @@
               </a:rPr>
               <a:t>Evidence from Drilling Data</a:t>
             </a:r>
-            <a:pPr indent="0" marL="0">
-              <a:buNone/>
-            </a:pPr>
             <a:r>
               <a:rPr lang="en-US" sz="1000" dirty="0">
                 <a:solidFill>
@@ -6367,7 +6079,7 @@
             <a:off x="685800" y="2688336"/>
             <a:ext cx="256032" cy="256032"/>
           </a:xfrm>
-          <a:prstGeom prst="oval">
+          <a:prstGeom prst="line">
             <a:avLst/>
           </a:prstGeom>
           <a:solidFill>
@@ -6397,7 +6109,7 @@
           <a:bodyPr wrap="square" lIns="0" tIns="0" rIns="0" bIns="0" rtlCol="0" anchor="ctr"/>
           <a:lstStyle/>
           <a:p>
-            <a:pPr algn="ctr" indent="0" marL="0">
+            <a:pPr marL="0" indent="0" algn="ctr">
               <a:buNone/>
             </a:pPr>
             <a:r>
@@ -6436,7 +6148,7 @@
           <a:bodyPr wrap="square" lIns="0" tIns="0" rIns="0" bIns="0" rtlCol="0" anchor="ctr"/>
           <a:lstStyle/>
           <a:p>
-            <a:pPr indent="0" marL="0">
+            <a:pPr marL="0" indent="0">
               <a:buNone/>
             </a:pPr>
             <a:r>
@@ -6447,9 +6159,6 @@
               </a:rPr>
               <a:t>Evidence from Daily Reports</a:t>
             </a:r>
-            <a:pPr indent="0" marL="0">
-              <a:buNone/>
-            </a:pPr>
             <a:r>
               <a:rPr lang="en-US" sz="1000" dirty="0">
                 <a:solidFill>
@@ -6473,7 +6182,7 @@
             <a:off x="685800" y="3118104"/>
             <a:ext cx="256032" cy="256032"/>
           </a:xfrm>
-          <a:prstGeom prst="oval">
+          <a:prstGeom prst="line">
             <a:avLst/>
           </a:prstGeom>
           <a:solidFill>
@@ -6503,7 +6212,7 @@
           <a:bodyPr wrap="square" lIns="0" tIns="0" rIns="0" bIns="0" rtlCol="0" anchor="ctr"/>
           <a:lstStyle/>
           <a:p>
-            <a:pPr algn="ctr" indent="0" marL="0">
+            <a:pPr marL="0" indent="0" algn="ctr">
               <a:buNone/>
             </a:pPr>
             <a:r>
@@ -6542,7 +6251,7 @@
           <a:bodyPr wrap="square" lIns="0" tIns="0" rIns="0" bIns="0" rtlCol="0" anchor="ctr"/>
           <a:lstStyle/>
           <a:p>
-            <a:pPr indent="0" marL="0">
+            <a:pPr marL="0" indent="0">
               <a:buNone/>
             </a:pPr>
             <a:r>
@@ -6553,9 +6262,6 @@
               </a:rPr>
               <a:t>Reasoning</a:t>
             </a:r>
-            <a:pPr indent="0" marL="0">
-              <a:buNone/>
-            </a:pPr>
             <a:r>
               <a:rPr lang="en-US" sz="1000" dirty="0">
                 <a:solidFill>
@@ -6579,7 +6285,7 @@
             <a:off x="685800" y="3547872"/>
             <a:ext cx="256032" cy="256032"/>
           </a:xfrm>
-          <a:prstGeom prst="oval">
+          <a:prstGeom prst="line">
             <a:avLst/>
           </a:prstGeom>
           <a:solidFill>
@@ -6609,7 +6315,7 @@
           <a:bodyPr wrap="square" lIns="0" tIns="0" rIns="0" bIns="0" rtlCol="0" anchor="ctr"/>
           <a:lstStyle/>
           <a:p>
-            <a:pPr algn="ctr" indent="0" marL="0">
+            <a:pPr marL="0" indent="0" algn="ctr">
               <a:buNone/>
             </a:pPr>
             <a:r>
@@ -6648,7 +6354,7 @@
           <a:bodyPr wrap="square" lIns="0" tIns="0" rIns="0" bIns="0" rtlCol="0" anchor="ctr"/>
           <a:lstStyle/>
           <a:p>
-            <a:pPr indent="0" marL="0">
+            <a:pPr marL="0" indent="0">
               <a:buNone/>
             </a:pPr>
             <a:r>
@@ -6659,9 +6365,6 @@
               </a:rPr>
               <a:t>Assumptions</a:t>
             </a:r>
-            <a:pPr indent="0" marL="0">
-              <a:buNone/>
-            </a:pPr>
             <a:r>
               <a:rPr lang="en-US" sz="1000" dirty="0">
                 <a:solidFill>
@@ -6685,7 +6388,7 @@
             <a:off x="685800" y="3977640"/>
             <a:ext cx="256032" cy="256032"/>
           </a:xfrm>
-          <a:prstGeom prst="oval">
+          <a:prstGeom prst="line">
             <a:avLst/>
           </a:prstGeom>
           <a:solidFill>
@@ -6715,7 +6418,7 @@
           <a:bodyPr wrap="square" lIns="0" tIns="0" rIns="0" bIns="0" rtlCol="0" anchor="ctr"/>
           <a:lstStyle/>
           <a:p>
-            <a:pPr algn="ctr" indent="0" marL="0">
+            <a:pPr marL="0" indent="0" algn="ctr">
               <a:buNone/>
             </a:pPr>
             <a:r>
@@ -6754,7 +6457,7 @@
           <a:bodyPr wrap="square" lIns="0" tIns="0" rIns="0" bIns="0" rtlCol="0" anchor="ctr"/>
           <a:lstStyle/>
           <a:p>
-            <a:pPr indent="0" marL="0">
+            <a:pPr marL="0" indent="0">
               <a:buNone/>
             </a:pPr>
             <a:r>
@@ -6765,9 +6468,6 @@
               </a:rPr>
               <a:t>Confidence &amp; Uncertainty</a:t>
             </a:r>
-            <a:pPr indent="0" marL="0">
-              <a:buNone/>
-            </a:pPr>
             <a:r>
               <a:rPr lang="en-US" sz="1000" dirty="0">
                 <a:solidFill>
@@ -6799,7 +6499,7 @@
           </a:solidFill>
           <a:ln/>
           <a:effectLst>
-            <a:outerShdw sx="100000" sy="100000" kx="0" ky="0" algn="bl" rotWithShape="0" blurRad="50800" dist="12700" dir="8100000">
+            <a:outerShdw blurRad="50800" dist="12700" dir="8100000" algn="bl" rotWithShape="0">
               <a:srgbClr val="000000">
                 <a:alpha val="8000"/>
               </a:srgbClr>
@@ -6848,7 +6548,7 @@
           <a:bodyPr wrap="square" lIns="0" tIns="0" rIns="0" bIns="0" rtlCol="0" anchor="ctr"/>
           <a:lstStyle/>
           <a:p>
-            <a:pPr indent="0" marL="0">
+            <a:pPr marL="0" indent="0">
               <a:buNone/>
             </a:pPr>
             <a:r>
@@ -6887,7 +6587,7 @@
           <a:bodyPr wrap="square" lIns="0" tIns="0" rIns="0" bIns="0" rtlCol="0" anchor="ctr"/>
           <a:lstStyle/>
           <a:p>
-            <a:pPr indent="0" marL="0">
+            <a:pPr marL="0" indent="0">
               <a:buNone/>
             </a:pPr>
             <a:r>
@@ -6901,7 +6601,7 @@
             <a:endParaRPr lang="en-US" sz="1050" dirty="0"/>
           </a:p>
           <a:p>
-            <a:pPr indent="0" marL="0">
+            <a:pPr marL="0" indent="0">
               <a:buNone/>
             </a:pPr>
             <a:r>
@@ -6937,7 +6637,7 @@
           <a:bodyPr wrap="square" lIns="0" tIns="0" rIns="0" bIns="0" rtlCol="0" anchor="ctr"/>
           <a:lstStyle/>
           <a:p>
-            <a:pPr indent="0" marL="0">
+            <a:pPr marL="0" indent="0">
               <a:buNone/>
             </a:pPr>
             <a:r>
@@ -6951,7 +6651,7 @@
             <a:endParaRPr lang="en-US" sz="1050" dirty="0"/>
           </a:p>
           <a:p>
-            <a:pPr indent="0" marL="0">
+            <a:pPr marL="0" indent="0">
               <a:buNone/>
             </a:pPr>
             <a:r>
@@ -6987,7 +6687,7 @@
           <a:bodyPr wrap="square" lIns="0" tIns="0" rIns="0" bIns="0" rtlCol="0" anchor="ctr"/>
           <a:lstStyle/>
           <a:p>
-            <a:pPr indent="0" marL="0">
+            <a:pPr marL="0" indent="0">
               <a:buNone/>
             </a:pPr>
             <a:r>
@@ -7001,7 +6701,7 @@
             <a:endParaRPr lang="en-US" sz="1050" dirty="0"/>
           </a:p>
           <a:p>
-            <a:pPr indent="0" marL="0">
+            <a:pPr marL="0" indent="0">
               <a:buNone/>
             </a:pPr>
             <a:r>
@@ -7037,7 +6737,7 @@
           <a:bodyPr wrap="square" lIns="0" tIns="0" rIns="0" bIns="0" rtlCol="0" anchor="ctr"/>
           <a:lstStyle/>
           <a:p>
-            <a:pPr indent="0" marL="0">
+            <a:pPr marL="0" indent="0">
               <a:buNone/>
             </a:pPr>
             <a:r>
@@ -7051,7 +6751,7 @@
             <a:endParaRPr lang="en-US" sz="1050" dirty="0"/>
           </a:p>
           <a:p>
-            <a:pPr indent="0" marL="0">
+            <a:pPr marL="0" indent="0">
               <a:buNone/>
             </a:pPr>
             <a:r>
@@ -7087,7 +6787,7 @@
           <a:bodyPr wrap="square" lIns="0" tIns="0" rIns="0" bIns="0" rtlCol="0" anchor="ctr"/>
           <a:lstStyle/>
           <a:p>
-            <a:pPr indent="0" marL="0">
+            <a:pPr marL="0" indent="0">
               <a:buNone/>
             </a:pPr>
             <a:r>
@@ -7101,7 +6801,7 @@
             <a:endParaRPr lang="en-US" sz="1050" dirty="0"/>
           </a:p>
           <a:p>
-            <a:pPr indent="0" marL="0">
+            <a:pPr marL="0" indent="0">
               <a:buNone/>
             </a:pPr>
             <a:r>
@@ -7132,6 +6832,7 @@
         <a:solidFill>
           <a:srgbClr val="F1F5F9"/>
         </a:solidFill>
+        <a:effectLst/>
       </p:bgPr>
     </p:bg>
     <p:spTree>
@@ -7189,7 +6890,7 @@
           <a:bodyPr wrap="square" lIns="0" tIns="0" rIns="0" bIns="0" rtlCol="0" anchor="ctr"/>
           <a:lstStyle/>
           <a:p>
-            <a:pPr indent="0" marL="0">
+            <a:pPr marL="0" indent="0">
               <a:buNone/>
             </a:pPr>
             <a:r>
@@ -7228,7 +6929,7 @@
           <a:bodyPr wrap="square" lIns="0" tIns="0" rIns="0" bIns="0" rtlCol="0" anchor="ctr"/>
           <a:lstStyle/>
           <a:p>
-            <a:pPr indent="0" marL="0">
+            <a:pPr marL="0" indent="0">
               <a:buNone/>
             </a:pPr>
             <a:r>
@@ -7267,7 +6968,7 @@
           <a:bodyPr wrap="square" lIns="0" tIns="0" rIns="0" bIns="0" rtlCol="0" anchor="ctr"/>
           <a:lstStyle/>
           <a:p>
-            <a:pPr indent="0" marL="0">
+            <a:pPr marL="0" indent="0">
               <a:buNone/>
             </a:pPr>
             <a:r>
@@ -7304,7 +7005,7 @@
           </a:solidFill>
           <a:ln/>
           <a:effectLst>
-            <a:outerShdw sx="100000" sy="100000" kx="0" ky="0" algn="bl" rotWithShape="0" blurRad="50800" dist="12700" dir="8100000">
+            <a:outerShdw blurRad="50800" dist="12700" dir="8100000" algn="bl" rotWithShape="0">
               <a:srgbClr val="000000">
                 <a:alpha val="8000"/>
               </a:srgbClr>
@@ -7333,7 +7034,7 @@
           <a:bodyPr wrap="square" lIns="0" tIns="0" rIns="0" bIns="0" rtlCol="0" anchor="ctr"/>
           <a:lstStyle/>
           <a:p>
-            <a:pPr indent="0" marL="0">
+            <a:pPr marL="0" indent="0">
               <a:buNone/>
             </a:pPr>
             <a:r>
@@ -7392,7 +7093,7 @@
           <a:bodyPr wrap="square" lIns="0" tIns="0" rIns="0" bIns="0" rtlCol="0" anchor="ctr"/>
           <a:lstStyle/>
           <a:p>
-            <a:pPr indent="0" marL="0">
+            <a:pPr marL="0" indent="0">
               <a:buNone/>
             </a:pPr>
             <a:r>
@@ -7403,9 +7104,6 @@
               </a:rPr>
               <a:t>Surface 26"  </a:t>
             </a:r>
-            <a:pPr indent="0" marL="0">
-              <a:buNone/>
-            </a:pPr>
             <a:r>
               <a:rPr lang="en-US" sz="900" dirty="0">
                 <a:solidFill>
@@ -7459,7 +7157,7 @@
           <a:bodyPr wrap="square" lIns="0" tIns="0" rIns="0" bIns="0" rtlCol="0" anchor="ctr"/>
           <a:lstStyle/>
           <a:p>
-            <a:pPr indent="0" marL="0">
+            <a:pPr marL="0" indent="0">
               <a:buNone/>
             </a:pPr>
             <a:r>
@@ -7470,9 +7168,6 @@
               </a:rPr>
               <a:t>Intermediate 17.5"  </a:t>
             </a:r>
-            <a:pPr indent="0" marL="0">
-              <a:buNone/>
-            </a:pPr>
             <a:r>
               <a:rPr lang="en-US" sz="900" dirty="0">
                 <a:solidFill>
@@ -7526,7 +7221,7 @@
           <a:bodyPr wrap="square" lIns="0" tIns="0" rIns="0" bIns="0" rtlCol="0" anchor="ctr"/>
           <a:lstStyle/>
           <a:p>
-            <a:pPr indent="0" marL="0">
+            <a:pPr marL="0" indent="0">
               <a:buNone/>
             </a:pPr>
             <a:r>
@@ -7537,9 +7232,6 @@
               </a:rPr>
               <a:t>Reservoir 8.5"  </a:t>
             </a:r>
-            <a:pPr indent="0" marL="0">
-              <a:buNone/>
-            </a:pPr>
             <a:r>
               <a:rPr lang="en-US" sz="900" dirty="0">
                 <a:solidFill>
@@ -7571,7 +7263,7 @@
           </a:solidFill>
           <a:ln/>
           <a:effectLst>
-            <a:outerShdw sx="100000" sy="100000" kx="0" ky="0" algn="bl" rotWithShape="0" blurRad="50800" dist="12700" dir="8100000">
+            <a:outerShdw blurRad="50800" dist="12700" dir="8100000" algn="bl" rotWithShape="0">
               <a:srgbClr val="000000">
                 <a:alpha val="8000"/>
               </a:srgbClr>
@@ -7620,7 +7312,7 @@
           <a:bodyPr wrap="square" lIns="0" tIns="0" rIns="0" bIns="0" rtlCol="0" anchor="ctr"/>
           <a:lstStyle/>
           <a:p>
-            <a:pPr indent="0" marL="0">
+            <a:pPr marL="0" indent="0">
               <a:buNone/>
             </a:pPr>
             <a:r>
@@ -7659,7 +7351,7 @@
           <a:bodyPr wrap="square" lIns="0" tIns="0" rIns="0" bIns="0" rtlCol="0" anchor="ctr"/>
           <a:lstStyle/>
           <a:p>
-            <a:pPr indent="0" marL="0">
+            <a:pPr marL="0" indent="0">
               <a:buNone/>
             </a:pPr>
             <a:r>
@@ -7670,12 +7362,6 @@
               </a:rPr>
               <a:t>DDR 2013-04-14:</a:t>
             </a:r>
-            <a:pPr indent="0" marL="0">
-              <a:spcAft>
-                <a:spcPts val="800"/>
-              </a:spcAft>
-              <a:buNone/>
-            </a:pPr>
             <a:r>
               <a:rPr lang="en-US" sz="900" i="1" dirty="0">
                 <a:solidFill>
@@ -7687,7 +7373,7 @@
             <a:endParaRPr lang="en-US" sz="900" dirty="0"/>
           </a:p>
           <a:p>
-            <a:pPr indent="0" marL="0">
+            <a:pPr marL="0" indent="0">
               <a:buNone/>
             </a:pPr>
             <a:r>
@@ -7698,9 +7384,6 @@
               </a:rPr>
               <a:t>DDR 2013-04-22:</a:t>
             </a:r>
-            <a:pPr indent="0" marL="0">
-              <a:buNone/>
-            </a:pPr>
             <a:r>
               <a:rPr lang="en-US" sz="900" i="1" dirty="0">
                 <a:solidFill>
@@ -7732,7 +7415,7 @@
           </a:solidFill>
           <a:ln/>
           <a:effectLst>
-            <a:outerShdw sx="100000" sy="100000" kx="0" ky="0" algn="bl" rotWithShape="0" blurRad="50800" dist="12700" dir="8100000">
+            <a:outerShdw blurRad="50800" dist="12700" dir="8100000" algn="bl" rotWithShape="0">
               <a:srgbClr val="000000">
                 <a:alpha val="8000"/>
               </a:srgbClr>
@@ -7761,7 +7444,7 @@
           <a:bodyPr wrap="square" lIns="0" tIns="0" rIns="0" bIns="0" rtlCol="0" anchor="ctr"/>
           <a:lstStyle/>
           <a:p>
-            <a:pPr indent="0" marL="0">
+            <a:pPr marL="0" indent="0">
               <a:buNone/>
             </a:pPr>
             <a:r>
@@ -7800,7 +7483,7 @@
           <a:bodyPr wrap="square" lIns="0" tIns="0" rIns="0" bIns="0" rtlCol="0" anchor="ctr"/>
           <a:lstStyle/>
           <a:p>
-            <a:pPr indent="0" marL="0">
+            <a:pPr marL="0" indent="0">
               <a:buNone/>
             </a:pPr>
             <a:r>
@@ -7817,7 +7500,7 @@
             <a:endParaRPr lang="en-US" sz="900" dirty="0"/>
           </a:p>
           <a:p>
-            <a:pPr indent="0" marL="0">
+            <a:pPr marL="0" indent="0">
               <a:buNone/>
             </a:pPr>
             <a:r>
@@ -7834,7 +7517,7 @@
             <a:endParaRPr lang="en-US" sz="900" dirty="0"/>
           </a:p>
           <a:p>
-            <a:pPr indent="0" marL="0">
+            <a:pPr marL="0" indent="0">
               <a:buNone/>
             </a:pPr>
             <a:r>
@@ -7871,7 +7554,7 @@
           </a:solidFill>
           <a:ln/>
           <a:effectLst>
-            <a:outerShdw sx="100000" sy="100000" kx="0" ky="0" algn="bl" rotWithShape="0" blurRad="50800" dist="12700" dir="8100000">
+            <a:outerShdw blurRad="50800" dist="12700" dir="8100000" algn="bl" rotWithShape="0">
               <a:srgbClr val="000000">
                 <a:alpha val="8000"/>
               </a:srgbClr>
@@ -7920,7 +7603,7 @@
           <a:bodyPr wrap="square" lIns="0" tIns="0" rIns="0" bIns="0" rtlCol="0" anchor="ctr"/>
           <a:lstStyle/>
           <a:p>
-            <a:pPr indent="0" marL="0">
+            <a:pPr marL="0" indent="0">
               <a:buNone/>
             </a:pPr>
             <a:r>
@@ -7959,7 +7642,7 @@
           <a:bodyPr wrap="square" lIns="0" tIns="0" rIns="0" bIns="0" rtlCol="0" anchor="ctr"/>
           <a:lstStyle/>
           <a:p>
-            <a:pPr indent="0" marL="0">
+            <a:pPr marL="0" indent="0">
               <a:buNone/>
             </a:pPr>
             <a:r>
@@ -7993,6 +7676,7 @@
         <a:solidFill>
           <a:srgbClr val="F1F5F9"/>
         </a:solidFill>
+        <a:effectLst/>
       </p:bgPr>
     </p:bg>
     <p:spTree>
@@ -8050,7 +7734,7 @@
           <a:bodyPr wrap="square" lIns="0" tIns="0" rIns="0" bIns="0" rtlCol="0" anchor="ctr"/>
           <a:lstStyle/>
           <a:p>
-            <a:pPr indent="0" marL="0">
+            <a:pPr marL="0" indent="0">
               <a:buNone/>
             </a:pPr>
             <a:r>
@@ -8089,7 +7773,7 @@
           <a:bodyPr wrap="square" lIns="0" tIns="0" rIns="0" bIns="0" rtlCol="0" anchor="ctr"/>
           <a:lstStyle/>
           <a:p>
-            <a:pPr indent="0" marL="0">
+            <a:pPr marL="0" indent="0">
               <a:buNone/>
             </a:pPr>
             <a:r>
@@ -8128,7 +7812,7 @@
           <a:bodyPr wrap="square" lIns="0" tIns="0" rIns="0" bIns="0" rtlCol="0" anchor="ctr"/>
           <a:lstStyle/>
           <a:p>
-            <a:pPr indent="0" marL="0">
+            <a:pPr marL="0" indent="0">
               <a:buNone/>
             </a:pPr>
             <a:r>
@@ -8165,7 +7849,7 @@
           </a:solidFill>
           <a:ln/>
           <a:effectLst>
-            <a:outerShdw sx="100000" sy="100000" kx="0" ky="0" algn="bl" rotWithShape="0" blurRad="50800" dist="12700" dir="8100000">
+            <a:outerShdw blurRad="50800" dist="12700" dir="8100000" algn="bl" rotWithShape="0">
               <a:srgbClr val="000000">
                 <a:alpha val="8000"/>
               </a:srgbClr>
@@ -8214,7 +7898,7 @@
           <a:bodyPr wrap="square" lIns="0" tIns="0" rIns="0" bIns="0" rtlCol="0" anchor="ctr"/>
           <a:lstStyle/>
           <a:p>
-            <a:pPr indent="0" marL="0">
+            <a:pPr marL="0" indent="0">
               <a:buNone/>
             </a:pPr>
             <a:r>
@@ -8253,7 +7937,7 @@
           <a:bodyPr wrap="square" lIns="0" tIns="0" rIns="0" bIns="0" rtlCol="0" anchor="ctr"/>
           <a:lstStyle/>
           <a:p>
-            <a:pPr indent="0" marL="0">
+            <a:pPr marL="0" indent="0">
               <a:buNone/>
             </a:pPr>
             <a:r>
@@ -8312,7 +7996,7 @@
           <a:bodyPr wrap="square" lIns="0" tIns="0" rIns="0" bIns="0" rtlCol="0" anchor="ctr"/>
           <a:lstStyle/>
           <a:p>
-            <a:pPr indent="0" marL="0">
+            <a:pPr marL="0" indent="0">
               <a:buNone/>
             </a:pPr>
             <a:r>
@@ -8349,7 +8033,7 @@
           </a:solidFill>
           <a:ln/>
           <a:effectLst>
-            <a:outerShdw sx="100000" sy="100000" kx="0" ky="0" algn="bl" rotWithShape="0" blurRad="50800" dist="12700" dir="8100000">
+            <a:outerShdw blurRad="50800" dist="12700" dir="8100000" algn="bl" rotWithShape="0">
               <a:srgbClr val="000000">
                 <a:alpha val="8000"/>
               </a:srgbClr>
@@ -8398,7 +8082,7 @@
           <a:bodyPr wrap="square" lIns="0" tIns="0" rIns="0" bIns="0" rtlCol="0" anchor="ctr"/>
           <a:lstStyle/>
           <a:p>
-            <a:pPr indent="0" marL="0">
+            <a:pPr marL="0" indent="0">
               <a:buNone/>
             </a:pPr>
             <a:r>
@@ -8437,7 +8121,7 @@
           <a:bodyPr wrap="square" lIns="0" tIns="0" rIns="0" bIns="0" rtlCol="0" anchor="ctr"/>
           <a:lstStyle/>
           <a:p>
-            <a:pPr indent="0" marL="0">
+            <a:pPr marL="0" indent="0">
               <a:buNone/>
             </a:pPr>
             <a:r>
@@ -8496,7 +8180,7 @@
           <a:bodyPr wrap="square" lIns="0" tIns="0" rIns="0" bIns="0" rtlCol="0" anchor="ctr"/>
           <a:lstStyle/>
           <a:p>
-            <a:pPr indent="0" marL="0">
+            <a:pPr marL="0" indent="0">
               <a:buNone/>
             </a:pPr>
             <a:r>
@@ -8533,7 +8217,7 @@
           </a:solidFill>
           <a:ln/>
           <a:effectLst>
-            <a:outerShdw sx="100000" sy="100000" kx="0" ky="0" algn="bl" rotWithShape="0" blurRad="50800" dist="12700" dir="8100000">
+            <a:outerShdw blurRad="50800" dist="12700" dir="8100000" algn="bl" rotWithShape="0">
               <a:srgbClr val="000000">
                 <a:alpha val="8000"/>
               </a:srgbClr>
@@ -8582,7 +8266,7 @@
           <a:bodyPr wrap="square" lIns="0" tIns="0" rIns="0" bIns="0" rtlCol="0" anchor="ctr"/>
           <a:lstStyle/>
           <a:p>
-            <a:pPr indent="0" marL="0">
+            <a:pPr marL="0" indent="0">
               <a:buNone/>
             </a:pPr>
             <a:r>
@@ -8621,7 +8305,7 @@
           <a:bodyPr wrap="square" lIns="0" tIns="0" rIns="0" bIns="0" rtlCol="0" anchor="ctr"/>
           <a:lstStyle/>
           <a:p>
-            <a:pPr indent="0" marL="0">
+            <a:pPr marL="0" indent="0">
               <a:buNone/>
             </a:pPr>
             <a:r>
@@ -8680,7 +8364,7 @@
           <a:bodyPr wrap="square" lIns="0" tIns="0" rIns="0" bIns="0" rtlCol="0" anchor="ctr"/>
           <a:lstStyle/>
           <a:p>
-            <a:pPr indent="0" marL="0">
+            <a:pPr marL="0" indent="0">
               <a:buNone/>
             </a:pPr>
             <a:r>
@@ -8717,7 +8401,7 @@
           </a:solidFill>
           <a:ln/>
           <a:effectLst>
-            <a:outerShdw sx="100000" sy="100000" kx="0" ky="0" algn="bl" rotWithShape="0" blurRad="50800" dist="12700" dir="8100000">
+            <a:outerShdw blurRad="50800" dist="12700" dir="8100000" algn="bl" rotWithShape="0">
               <a:srgbClr val="000000">
                 <a:alpha val="8000"/>
               </a:srgbClr>
@@ -8766,7 +8450,7 @@
           <a:bodyPr wrap="square" lIns="0" tIns="0" rIns="0" bIns="0" rtlCol="0" anchor="ctr"/>
           <a:lstStyle/>
           <a:p>
-            <a:pPr indent="0" marL="0">
+            <a:pPr marL="0" indent="0">
               <a:buNone/>
             </a:pPr>
             <a:r>
@@ -8805,7 +8489,7 @@
           <a:bodyPr wrap="square" lIns="0" tIns="0" rIns="0" bIns="0" rtlCol="0" anchor="ctr"/>
           <a:lstStyle/>
           <a:p>
-            <a:pPr indent="0" marL="0">
+            <a:pPr marL="0" indent="0">
               <a:buNone/>
             </a:pPr>
             <a:r>
@@ -8864,7 +8548,7 @@
           <a:bodyPr wrap="square" lIns="0" tIns="0" rIns="0" bIns="0" rtlCol="0" anchor="ctr"/>
           <a:lstStyle/>
           <a:p>
-            <a:pPr indent="0" marL="0">
+            <a:pPr marL="0" indent="0">
               <a:buNone/>
             </a:pPr>
             <a:r>
@@ -8901,7 +8585,7 @@
           </a:solidFill>
           <a:ln/>
           <a:effectLst>
-            <a:outerShdw sx="100000" sy="100000" kx="0" ky="0" algn="bl" rotWithShape="0" blurRad="50800" dist="12700" dir="8100000">
+            <a:outerShdw blurRad="50800" dist="12700" dir="8100000" algn="bl" rotWithShape="0">
               <a:srgbClr val="000000">
                 <a:alpha val="8000"/>
               </a:srgbClr>
@@ -8950,7 +8634,7 @@
           <a:bodyPr wrap="square" lIns="0" tIns="0" rIns="0" bIns="0" rtlCol="0" anchor="ctr"/>
           <a:lstStyle/>
           <a:p>
-            <a:pPr indent="0" marL="0">
+            <a:pPr marL="0" indent="0">
               <a:buNone/>
             </a:pPr>
             <a:r>
@@ -8989,7 +8673,7 @@
           <a:bodyPr wrap="square" lIns="0" tIns="0" rIns="0" bIns="0" rtlCol="0" anchor="ctr"/>
           <a:lstStyle/>
           <a:p>
-            <a:pPr indent="0" marL="0">
+            <a:pPr marL="0" indent="0">
               <a:buNone/>
             </a:pPr>
             <a:r>
@@ -9048,7 +8732,7 @@
           <a:bodyPr wrap="square" lIns="0" tIns="0" rIns="0" bIns="0" rtlCol="0" anchor="ctr"/>
           <a:lstStyle/>
           <a:p>
-            <a:pPr indent="0" marL="0">
+            <a:pPr marL="0" indent="0">
               <a:buNone/>
             </a:pPr>
             <a:r>
@@ -9082,6 +8766,7 @@
         <a:solidFill>
           <a:srgbClr val="142038"/>
         </a:solidFill>
+        <a:effectLst/>
       </p:bgPr>
     </p:bg>
     <p:spTree>
@@ -9119,7 +8804,7 @@
           <a:bodyPr wrap="square" lIns="0" tIns="0" rIns="0" bIns="0" rtlCol="0" anchor="ctr"/>
           <a:lstStyle/>
           <a:p>
-            <a:pPr indent="0" marL="0">
+            <a:pPr marL="0" indent="0">
               <a:buNone/>
             </a:pPr>
             <a:r>
@@ -9158,7 +8843,7 @@
           <a:bodyPr wrap="square" lIns="0" tIns="0" rIns="0" bIns="0" rtlCol="0" anchor="ctr"/>
           <a:lstStyle/>
           <a:p>
-            <a:pPr indent="0" marL="0">
+            <a:pPr marL="0" indent="0">
               <a:buNone/>
             </a:pPr>
             <a:r>
@@ -9195,7 +8880,7 @@
           </a:solidFill>
           <a:ln/>
           <a:effectLst>
-            <a:outerShdw sx="100000" sy="100000" kx="0" ky="0" algn="bl" rotWithShape="0" blurRad="76200" dist="25400" dir="8100000">
+            <a:outerShdw blurRad="76200" dist="25400" dir="8100000" algn="bl" rotWithShape="0">
               <a:srgbClr val="000000">
                 <a:alpha val="10000"/>
               </a:srgbClr>
@@ -9234,7 +8919,7 @@
             <a:off x="640080" y="1298448"/>
             <a:ext cx="128016" cy="128016"/>
           </a:xfrm>
-          <a:prstGeom prst="oval">
+          <a:prstGeom prst="line">
             <a:avLst/>
           </a:prstGeom>
           <a:solidFill>
@@ -9254,7 +8939,7 @@
             <a:off x="841248" y="1298448"/>
             <a:ext cx="128016" cy="128016"/>
           </a:xfrm>
-          <a:prstGeom prst="oval">
+          <a:prstGeom prst="line">
             <a:avLst/>
           </a:prstGeom>
           <a:solidFill>
@@ -9274,7 +8959,7 @@
             <a:off x="1042416" y="1298448"/>
             <a:ext cx="128016" cy="128016"/>
           </a:xfrm>
-          <a:prstGeom prst="oval">
+          <a:prstGeom prst="line">
             <a:avLst/>
           </a:prstGeom>
           <a:solidFill>
@@ -9304,7 +8989,7 @@
           <a:bodyPr wrap="square" lIns="0" tIns="0" rIns="0" bIns="0" rtlCol="0" anchor="ctr"/>
           <a:lstStyle/>
           <a:p>
-            <a:pPr indent="0" marL="0">
+            <a:pPr marL="0" indent="0">
               <a:spcAft>
                 <a:spcPts val="100"/>
               </a:spcAft>
@@ -9324,7 +9009,7 @@
             <a:endParaRPr lang="en-US" sz="900" dirty="0"/>
           </a:p>
           <a:p>
-            <a:pPr indent="0" marL="0">
+            <a:pPr marL="0" indent="0">
               <a:spcAft>
                 <a:spcPts val="100"/>
               </a:spcAft>
@@ -9344,7 +9029,7 @@
             <a:endParaRPr lang="en-US" sz="900" dirty="0"/>
           </a:p>
           <a:p>
-            <a:pPr indent="0" marL="0">
+            <a:pPr marL="0" indent="0">
               <a:spcAft>
                 <a:spcPts val="100"/>
               </a:spcAft>
@@ -9364,7 +9049,7 @@
             <a:endParaRPr lang="en-US" sz="900" dirty="0"/>
           </a:p>
           <a:p>
-            <a:pPr indent="0" marL="0">
+            <a:pPr marL="0" indent="0">
               <a:spcAft>
                 <a:spcPts val="100"/>
               </a:spcAft>
@@ -9384,7 +9069,7 @@
             <a:endParaRPr lang="en-US" sz="900" dirty="0"/>
           </a:p>
           <a:p>
-            <a:pPr indent="0" marL="0">
+            <a:pPr marL="0" indent="0">
               <a:spcAft>
                 <a:spcPts val="100"/>
               </a:spcAft>
@@ -9404,7 +9089,7 @@
             <a:endParaRPr lang="en-US" sz="900" dirty="0"/>
           </a:p>
           <a:p>
-            <a:pPr indent="0" marL="0">
+            <a:pPr marL="0" indent="0">
               <a:spcAft>
                 <a:spcPts val="100"/>
               </a:spcAft>
@@ -9424,7 +9109,7 @@
             <a:endParaRPr lang="en-US" sz="900" dirty="0"/>
           </a:p>
           <a:p>
-            <a:pPr indent="0" marL="0">
+            <a:pPr marL="0" indent="0">
               <a:spcAft>
                 <a:spcPts val="100"/>
               </a:spcAft>
@@ -9444,7 +9129,7 @@
             <a:endParaRPr lang="en-US" sz="900" dirty="0"/>
           </a:p>
           <a:p>
-            <a:pPr indent="0" marL="0">
+            <a:pPr marL="0" indent="0">
               <a:spcAft>
                 <a:spcPts val="100"/>
               </a:spcAft>
@@ -9464,7 +9149,7 @@
             <a:endParaRPr lang="en-US" sz="900" dirty="0"/>
           </a:p>
           <a:p>
-            <a:pPr indent="0" marL="0">
+            <a:pPr marL="0" indent="0">
               <a:spcAft>
                 <a:spcPts val="100"/>
               </a:spcAft>
@@ -9484,7 +9169,7 @@
             <a:endParaRPr lang="en-US" sz="900" dirty="0"/>
           </a:p>
           <a:p>
-            <a:pPr indent="0" marL="0">
+            <a:pPr marL="0" indent="0">
               <a:spcAft>
                 <a:spcPts val="100"/>
               </a:spcAft>
@@ -9504,7 +9189,7 @@
             <a:endParaRPr lang="en-US" sz="900" dirty="0"/>
           </a:p>
           <a:p>
-            <a:pPr indent="0" marL="0">
+            <a:pPr marL="0" indent="0">
               <a:spcAft>
                 <a:spcPts val="100"/>
               </a:spcAft>
@@ -9524,7 +9209,7 @@
             <a:endParaRPr lang="en-US" sz="900" dirty="0"/>
           </a:p>
           <a:p>
-            <a:pPr indent="0" marL="0">
+            <a:pPr marL="0" indent="0">
               <a:spcAft>
                 <a:spcPts val="100"/>
               </a:spcAft>
@@ -9566,7 +9251,7 @@
           <a:bodyPr wrap="square" lIns="0" tIns="0" rIns="0" bIns="0" rtlCol="0" anchor="ctr"/>
           <a:lstStyle/>
           <a:p>
-            <a:pPr indent="0" marL="0">
+            <a:pPr marL="0" indent="0">
               <a:buNone/>
             </a:pPr>
             <a:r>
@@ -9600,6 +9285,7 @@
         <a:solidFill>
           <a:srgbClr val="F1F5F9"/>
         </a:solidFill>
+        <a:effectLst/>
       </p:bgPr>
     </p:bg>
     <p:spTree>
@@ -9657,7 +9343,7 @@
           <a:bodyPr wrap="square" lIns="0" tIns="0" rIns="0" bIns="0" rtlCol="0" anchor="ctr"/>
           <a:lstStyle/>
           <a:p>
-            <a:pPr indent="0" marL="0">
+            <a:pPr marL="0" indent="0">
               <a:buNone/>
             </a:pPr>
             <a:r>
@@ -9696,7 +9382,7 @@
           <a:bodyPr wrap="square" lIns="0" tIns="0" rIns="0" bIns="0" rtlCol="0" anchor="ctr"/>
           <a:lstStyle/>
           <a:p>
-            <a:pPr indent="0" marL="0">
+            <a:pPr marL="0" indent="0">
               <a:buNone/>
             </a:pPr>
             <a:r>
@@ -9735,7 +9421,7 @@
           <a:bodyPr wrap="square" lIns="0" tIns="0" rIns="0" bIns="0" rtlCol="0" anchor="ctr"/>
           <a:lstStyle/>
           <a:p>
-            <a:pPr indent="0" marL="0">
+            <a:pPr marL="0" indent="0">
               <a:buNone/>
             </a:pPr>
             <a:r>
@@ -9772,7 +9458,7 @@
           </a:solidFill>
           <a:ln/>
           <a:effectLst>
-            <a:outerShdw sx="100000" sy="100000" kx="0" ky="0" algn="bl" rotWithShape="0" blurRad="50800" dist="12700" dir="8100000">
+            <a:outerShdw blurRad="50800" dist="12700" dir="8100000" algn="bl" rotWithShape="0">
               <a:srgbClr val="000000">
                 <a:alpha val="8000"/>
               </a:srgbClr>
@@ -9821,7 +9507,7 @@
           <a:bodyPr wrap="square" lIns="0" tIns="0" rIns="0" bIns="0" rtlCol="0" anchor="ctr"/>
           <a:lstStyle/>
           <a:p>
-            <a:pPr indent="0" marL="0">
+            <a:pPr marL="0" indent="0">
               <a:buNone/>
             </a:pPr>
             <a:r>
@@ -9964,7 +9650,7 @@
           </a:solidFill>
           <a:ln/>
           <a:effectLst>
-            <a:outerShdw sx="100000" sy="100000" kx="0" ky="0" algn="bl" rotWithShape="0" blurRad="50800" dist="12700" dir="8100000">
+            <a:outerShdw blurRad="50800" dist="12700" dir="8100000" algn="bl" rotWithShape="0">
               <a:srgbClr val="000000">
                 <a:alpha val="8000"/>
               </a:srgbClr>
@@ -10013,7 +9699,7 @@
           <a:bodyPr wrap="square" lIns="0" tIns="0" rIns="0" bIns="0" rtlCol="0" anchor="ctr"/>
           <a:lstStyle/>
           <a:p>
-            <a:pPr indent="0" marL="0">
+            <a:pPr marL="0" indent="0">
               <a:buNone/>
             </a:pPr>
             <a:r>
@@ -10156,7 +9842,7 @@
           </a:solidFill>
           <a:ln/>
           <a:effectLst>
-            <a:outerShdw sx="100000" sy="100000" kx="0" ky="0" algn="bl" rotWithShape="0" blurRad="50800" dist="12700" dir="8100000">
+            <a:outerShdw blurRad="50800" dist="12700" dir="8100000" algn="bl" rotWithShape="0">
               <a:srgbClr val="000000">
                 <a:alpha val="8000"/>
               </a:srgbClr>
@@ -10205,7 +9891,7 @@
           <a:bodyPr wrap="square" lIns="0" tIns="0" rIns="0" bIns="0" rtlCol="0" anchor="ctr"/>
           <a:lstStyle/>
           <a:p>
-            <a:pPr indent="0" marL="0">
+            <a:pPr marL="0" indent="0">
               <a:buNone/>
             </a:pPr>
             <a:r>
@@ -10348,7 +10034,7 @@
           </a:solidFill>
           <a:ln/>
           <a:effectLst>
-            <a:outerShdw sx="100000" sy="100000" kx="0" ky="0" algn="bl" rotWithShape="0" blurRad="50800" dist="12700" dir="8100000">
+            <a:outerShdw blurRad="50800" dist="12700" dir="8100000" algn="bl" rotWithShape="0">
               <a:srgbClr val="000000">
                 <a:alpha val="8000"/>
               </a:srgbClr>
@@ -10397,7 +10083,7 @@
           <a:bodyPr wrap="square" lIns="0" tIns="0" rIns="0" bIns="0" rtlCol="0" anchor="ctr"/>
           <a:lstStyle/>
           <a:p>
-            <a:pPr indent="0" marL="0">
+            <a:pPr marL="0" indent="0">
               <a:buNone/>
             </a:pPr>
             <a:r>
@@ -10822,4 +10508,319 @@
     </a:ext>
   </a:extLst>
 </a:theme>
+</file>
+
+<file path=ppt/theme/theme2.xml><?xml version="1.0" encoding="utf-8"?>
+<a:theme xmlns:a="http://schemas.openxmlformats.org/drawingml/2006/main" name="Office Theme">
+  <a:themeElements>
+    <a:clrScheme name="Office">
+      <a:dk1>
+        <a:sysClr val="windowText" lastClr="000000"/>
+      </a:dk1>
+      <a:lt1>
+        <a:sysClr val="window" lastClr="FFFFFF"/>
+      </a:lt1>
+      <a:dk2>
+        <a:srgbClr val="0E2841"/>
+      </a:dk2>
+      <a:lt2>
+        <a:srgbClr val="E8E8E8"/>
+      </a:lt2>
+      <a:accent1>
+        <a:srgbClr val="156082"/>
+      </a:accent1>
+      <a:accent2>
+        <a:srgbClr val="E97132"/>
+      </a:accent2>
+      <a:accent3>
+        <a:srgbClr val="196B24"/>
+      </a:accent3>
+      <a:accent4>
+        <a:srgbClr val="0F9ED5"/>
+      </a:accent4>
+      <a:accent5>
+        <a:srgbClr val="A02B93"/>
+      </a:accent5>
+      <a:accent6>
+        <a:srgbClr val="4EA72E"/>
+      </a:accent6>
+      <a:hlink>
+        <a:srgbClr val="467886"/>
+      </a:hlink>
+      <a:folHlink>
+        <a:srgbClr val="96607D"/>
+      </a:folHlink>
+    </a:clrScheme>
+    <a:fontScheme name="Office">
+      <a:majorFont>
+        <a:latin typeface="Aptos Display" panose="02110004020202020204"/>
+        <a:ea typeface=""/>
+        <a:cs typeface=""/>
+        <a:font script="Jpan" typeface="游ゴシック Light"/>
+        <a:font script="Hang" typeface="맑은 고딕"/>
+        <a:font script="Hans" typeface="等线 Light"/>
+        <a:font script="Hant" typeface="新細明體"/>
+        <a:font script="Arab" typeface="Times New Roman"/>
+        <a:font script="Hebr" typeface="Times New Roman"/>
+        <a:font script="Thai" typeface="Angsana New"/>
+        <a:font script="Ethi" typeface="Nyala"/>
+        <a:font script="Beng" typeface="Vrinda"/>
+        <a:font script="Gujr" typeface="Shruti"/>
+        <a:font script="Khmr" typeface="MoolBoran"/>
+        <a:font script="Knda" typeface="Tunga"/>
+        <a:font script="Guru" typeface="Raavi"/>
+        <a:font script="Cans" typeface="Euphemia"/>
+        <a:font script="Cher" typeface="Plantagenet Cherokee"/>
+        <a:font script="Yiii" typeface="Microsoft Yi Baiti"/>
+        <a:font script="Tibt" typeface="Microsoft Himalaya"/>
+        <a:font script="Thaa" typeface="MV Boli"/>
+        <a:font script="Deva" typeface="Mangal"/>
+        <a:font script="Telu" typeface="Gautami"/>
+        <a:font script="Taml" typeface="Latha"/>
+        <a:font script="Syrc" typeface="Estrangelo Edessa"/>
+        <a:font script="Orya" typeface="Kalinga"/>
+        <a:font script="Mlym" typeface="Kartika"/>
+        <a:font script="Laoo" typeface="DokChampa"/>
+        <a:font script="Sinh" typeface="Iskoola Pota"/>
+        <a:font script="Mong" typeface="Mongolian Baiti"/>
+        <a:font script="Viet" typeface="Times New Roman"/>
+        <a:font script="Uigh" typeface="Microsoft Uighur"/>
+        <a:font script="Geor" typeface="Sylfaen"/>
+        <a:font script="Armn" typeface="Arial"/>
+        <a:font script="Bugi" typeface="Leelawadee UI"/>
+        <a:font script="Bopo" typeface="Microsoft JhengHei"/>
+        <a:font script="Java" typeface="Javanese Text"/>
+        <a:font script="Lisu" typeface="Segoe UI"/>
+        <a:font script="Mymr" typeface="Myanmar Text"/>
+        <a:font script="Nkoo" typeface="Ebrima"/>
+        <a:font script="Olck" typeface="Nirmala UI"/>
+        <a:font script="Osma" typeface="Ebrima"/>
+        <a:font script="Phag" typeface="Phagspa"/>
+        <a:font script="Syrn" typeface="Estrangelo Edessa"/>
+        <a:font script="Syrj" typeface="Estrangelo Edessa"/>
+        <a:font script="Syre" typeface="Estrangelo Edessa"/>
+        <a:font script="Sora" typeface="Nirmala UI"/>
+        <a:font script="Tale" typeface="Microsoft Tai Le"/>
+        <a:font script="Talu" typeface="Microsoft New Tai Lue"/>
+        <a:font script="Tfng" typeface="Ebrima"/>
+      </a:majorFont>
+      <a:minorFont>
+        <a:latin typeface="Aptos" panose="02110004020202020204"/>
+        <a:ea typeface=""/>
+        <a:cs typeface=""/>
+        <a:font script="Jpan" typeface="游ゴシック"/>
+        <a:font script="Hang" typeface="맑은 고딕"/>
+        <a:font script="Hans" typeface="等线"/>
+        <a:font script="Hant" typeface="新細明體"/>
+        <a:font script="Arab" typeface="Arial"/>
+        <a:font script="Hebr" typeface="Arial"/>
+        <a:font script="Thai" typeface="Cordia New"/>
+        <a:font script="Ethi" typeface="Nyala"/>
+        <a:font script="Beng" typeface="Vrinda"/>
+        <a:font script="Gujr" typeface="Shruti"/>
+        <a:font script="Khmr" typeface="DaunPenh"/>
+        <a:font script="Knda" typeface="Tunga"/>
+        <a:font script="Guru" typeface="Raavi"/>
+        <a:font script="Cans" typeface="Euphemia"/>
+        <a:font script="Cher" typeface="Plantagenet Cherokee"/>
+        <a:font script="Yiii" typeface="Microsoft Yi Baiti"/>
+        <a:font script="Tibt" typeface="Microsoft Himalaya"/>
+        <a:font script="Thaa" typeface="MV Boli"/>
+        <a:font script="Deva" typeface="Mangal"/>
+        <a:font script="Telu" typeface="Gautami"/>
+        <a:font script="Taml" typeface="Latha"/>
+        <a:font script="Syrc" typeface="Estrangelo Edessa"/>
+        <a:font script="Orya" typeface="Kalinga"/>
+        <a:font script="Mlym" typeface="Kartika"/>
+        <a:font script="Laoo" typeface="DokChampa"/>
+        <a:font script="Sinh" typeface="Iskoola Pota"/>
+        <a:font script="Mong" typeface="Mongolian Baiti"/>
+        <a:font script="Viet" typeface="Arial"/>
+        <a:font script="Uigh" typeface="Microsoft Uighur"/>
+        <a:font script="Geor" typeface="Sylfaen"/>
+        <a:font script="Armn" typeface="Arial"/>
+        <a:font script="Bugi" typeface="Leelawadee UI"/>
+        <a:font script="Bopo" typeface="Microsoft JhengHei"/>
+        <a:font script="Java" typeface="Javanese Text"/>
+        <a:font script="Lisu" typeface="Segoe UI"/>
+        <a:font script="Mymr" typeface="Myanmar Text"/>
+        <a:font script="Nkoo" typeface="Ebrima"/>
+        <a:font script="Olck" typeface="Nirmala UI"/>
+        <a:font script="Osma" typeface="Ebrima"/>
+        <a:font script="Phag" typeface="Phagspa"/>
+        <a:font script="Syrn" typeface="Estrangelo Edessa"/>
+        <a:font script="Syrj" typeface="Estrangelo Edessa"/>
+        <a:font script="Syre" typeface="Estrangelo Edessa"/>
+        <a:font script="Sora" typeface="Nirmala UI"/>
+        <a:font script="Tale" typeface="Microsoft Tai Le"/>
+        <a:font script="Talu" typeface="Microsoft New Tai Lue"/>
+        <a:font script="Tfng" typeface="Ebrima"/>
+      </a:minorFont>
+    </a:fontScheme>
+    <a:fmtScheme name="Office">
+      <a:fillStyleLst>
+        <a:solidFill>
+          <a:schemeClr val="phClr"/>
+        </a:solidFill>
+        <a:gradFill rotWithShape="1">
+          <a:gsLst>
+            <a:gs pos="0">
+              <a:schemeClr val="phClr">
+                <a:lumMod val="110000"/>
+                <a:satMod val="105000"/>
+                <a:tint val="67000"/>
+              </a:schemeClr>
+            </a:gs>
+            <a:gs pos="50000">
+              <a:schemeClr val="phClr">
+                <a:lumMod val="105000"/>
+                <a:satMod val="103000"/>
+                <a:tint val="73000"/>
+              </a:schemeClr>
+            </a:gs>
+            <a:gs pos="100000">
+              <a:schemeClr val="phClr">
+                <a:lumMod val="105000"/>
+                <a:satMod val="109000"/>
+                <a:tint val="81000"/>
+              </a:schemeClr>
+            </a:gs>
+          </a:gsLst>
+          <a:lin ang="5400000" scaled="0"/>
+        </a:gradFill>
+        <a:gradFill rotWithShape="1">
+          <a:gsLst>
+            <a:gs pos="0">
+              <a:schemeClr val="phClr">
+                <a:satMod val="103000"/>
+                <a:lumMod val="102000"/>
+                <a:tint val="94000"/>
+              </a:schemeClr>
+            </a:gs>
+            <a:gs pos="50000">
+              <a:schemeClr val="phClr">
+                <a:satMod val="110000"/>
+                <a:lumMod val="100000"/>
+                <a:shade val="100000"/>
+              </a:schemeClr>
+            </a:gs>
+            <a:gs pos="100000">
+              <a:schemeClr val="phClr">
+                <a:lumMod val="99000"/>
+                <a:satMod val="120000"/>
+                <a:shade val="78000"/>
+              </a:schemeClr>
+            </a:gs>
+          </a:gsLst>
+          <a:lin ang="5400000" scaled="0"/>
+        </a:gradFill>
+      </a:fillStyleLst>
+      <a:lnStyleLst>
+        <a:ln w="12700" cap="flat" cmpd="sng" algn="ctr">
+          <a:solidFill>
+            <a:schemeClr val="phClr"/>
+          </a:solidFill>
+          <a:prstDash val="solid"/>
+          <a:miter lim="800000"/>
+        </a:ln>
+        <a:ln w="19050" cap="flat" cmpd="sng" algn="ctr">
+          <a:solidFill>
+            <a:schemeClr val="phClr"/>
+          </a:solidFill>
+          <a:prstDash val="solid"/>
+          <a:miter lim="800000"/>
+        </a:ln>
+        <a:ln w="25400" cap="flat" cmpd="sng" algn="ctr">
+          <a:solidFill>
+            <a:schemeClr val="phClr"/>
+          </a:solidFill>
+          <a:prstDash val="solid"/>
+          <a:miter lim="800000"/>
+        </a:ln>
+      </a:lnStyleLst>
+      <a:effectStyleLst>
+        <a:effectStyle>
+          <a:effectLst/>
+        </a:effectStyle>
+        <a:effectStyle>
+          <a:effectLst/>
+        </a:effectStyle>
+        <a:effectStyle>
+          <a:effectLst>
+            <a:outerShdw blurRad="57150" dist="19050" dir="5400000" algn="ctr" rotWithShape="0">
+              <a:srgbClr val="000000">
+                <a:alpha val="63000"/>
+              </a:srgbClr>
+            </a:outerShdw>
+          </a:effectLst>
+        </a:effectStyle>
+      </a:effectStyleLst>
+      <a:bgFillStyleLst>
+        <a:solidFill>
+          <a:schemeClr val="phClr"/>
+        </a:solidFill>
+        <a:solidFill>
+          <a:schemeClr val="phClr">
+            <a:tint val="95000"/>
+            <a:satMod val="170000"/>
+          </a:schemeClr>
+        </a:solidFill>
+        <a:gradFill rotWithShape="1">
+          <a:gsLst>
+            <a:gs pos="0">
+              <a:schemeClr val="phClr">
+                <a:tint val="93000"/>
+                <a:satMod val="150000"/>
+                <a:shade val="98000"/>
+                <a:lumMod val="102000"/>
+              </a:schemeClr>
+            </a:gs>
+            <a:gs pos="50000">
+              <a:schemeClr val="phClr">
+                <a:tint val="98000"/>
+                <a:satMod val="130000"/>
+                <a:shade val="90000"/>
+                <a:lumMod val="103000"/>
+              </a:schemeClr>
+            </a:gs>
+            <a:gs pos="100000">
+              <a:schemeClr val="phClr">
+                <a:shade val="63000"/>
+                <a:satMod val="120000"/>
+              </a:schemeClr>
+            </a:gs>
+          </a:gsLst>
+          <a:lin ang="5400000" scaled="0"/>
+        </a:gradFill>
+      </a:bgFillStyleLst>
+    </a:fmtScheme>
+  </a:themeElements>
+  <a:objectDefaults>
+    <a:lnDef>
+      <a:spPr/>
+      <a:bodyPr/>
+      <a:lstStyle/>
+      <a:style>
+        <a:lnRef idx="2">
+          <a:schemeClr val="accent1"/>
+        </a:lnRef>
+        <a:fillRef idx="0">
+          <a:schemeClr val="accent1"/>
+        </a:fillRef>
+        <a:effectRef idx="1">
+          <a:schemeClr val="accent1"/>
+        </a:effectRef>
+        <a:fontRef idx="minor">
+          <a:schemeClr val="tx1"/>
+        </a:fontRef>
+      </a:style>
+    </a:lnDef>
+  </a:objectDefaults>
+  <a:extraClrSchemeLst/>
+  <a:extLst>
+    <a:ext uri="{05A4C25C-085E-4340-85A3-A5531E510DB2}">
+      <thm15:themeFamily xmlns:thm15="http://schemas.microsoft.com/office/thememl/2012/main" name="Office Theme" id="{2E142A2C-CD16-42D6-873A-C26D2A0506FA}" vid="{1BDDFF52-6CD6-40A5-AB3C-68EB2F1E4D0A}"/>
+    </a:ext>
+  </a:extLst>
+</a:theme>
 </file>
</xml_diff>